<commit_message>
Updated project presentation slides
</commit_message>
<xml_diff>
--- a/Final_Digital_FIR_Final_FYP_Presentation.pptx
+++ b/Final_Digital_FIR_Final_FYP_Presentation.pptx
@@ -280,7 +280,7 @@
       </p15:sldGuideLst>
     </p:ext>
     <p:ext uri="http://customooxmlschemas.google.com/">
-      <go:slidesCustomData xmlns="" xmlns:mc="http://schemas.openxmlformats.org/markup-compatibility/2006" xmlns:mv="urn:schemas-microsoft-com:mac:vml" xmlns:c="http://schemas.openxmlformats.org/drawingml/2006/chart" xmlns:dgm="http://schemas.openxmlformats.org/drawingml/2006/diagram" xmlns:o="urn:schemas-microsoft-com:office:office" xmlns:v="urn:schemas-microsoft-com:vml" xmlns:pvml="urn:schemas-microsoft-com:office:powerpoint" xmlns:com="http://schemas.openxmlformats.org/drawingml/2006/compatibility" xmlns:p14="http://schemas.microsoft.com/office/powerpoint/2010/main" xmlns:p15="http://schemas.microsoft.com/office/powerpoint/2012/main" xmlns:ahyp="http://schemas.microsoft.com/office/drawing/2018/hyperlinkcolor" xmlns:go="http://customooxmlschemas.google.com/" r:id="rId27" roundtripDataSignature="AMtx7mgqso+muD7qxSKyk66oXGt+27nMBQ=="/>
+      <go:slidesCustomData xmlns:go="http://customooxmlschemas.google.com/" xmlns:ahyp="http://schemas.microsoft.com/office/drawing/2018/hyperlinkcolor" xmlns:p15="http://schemas.microsoft.com/office/powerpoint/2012/main" xmlns:p14="http://schemas.microsoft.com/office/powerpoint/2010/main" xmlns:com="http://schemas.openxmlformats.org/drawingml/2006/compatibility" xmlns:pvml="urn:schemas-microsoft-com:office:powerpoint" xmlns:v="urn:schemas-microsoft-com:vml" xmlns:o="urn:schemas-microsoft-com:office:office" xmlns:dgm="http://schemas.openxmlformats.org/drawingml/2006/diagram" xmlns:c="http://schemas.openxmlformats.org/drawingml/2006/chart" xmlns:mv="urn:schemas-microsoft-com:mac:vml" xmlns:mc="http://schemas.openxmlformats.org/markup-compatibility/2006" xmlns="" r:id="rId27" roundtripDataSignature="AMtx7mgqso+muD7qxSKyk66oXGt+27nMBQ=="/>
     </p:ext>
   </p:extLst>
 </p:presentation>
@@ -16569,18 +16569,9 @@
                 </a:solidFill>
                 <a:latin typeface="Arial"/>
               </a:rPr>
-              <a:t>A Blockchain Based Secure First Information Report Management </a:t>
+              <a:t>A Blockchain Based Secure First Information Report Management System</a:t>
             </a:r>
-            <a:r>
-              <a:rPr sz="1800" dirty="0" smtClean="0">
-                <a:solidFill>
-                  <a:srgbClr val="141414"/>
-                </a:solidFill>
-                <a:latin typeface="Arial"/>
-              </a:rPr>
-              <a:t>System</a:t>
-            </a:r>
-            <a:endParaRPr lang="en-US" sz="1800" dirty="0" smtClean="0">
+            <a:endParaRPr lang="en-US" sz="1800" dirty="0">
               <a:solidFill>
                 <a:srgbClr val="141414"/>
               </a:solidFill>
@@ -16589,7 +16580,7 @@
           </a:p>
           <a:p>
             <a:pPr algn="ctr"/>
-            <a:endParaRPr lang="en-US" sz="1800" b="0" dirty="0" smtClean="0">
+            <a:endParaRPr lang="en-US" sz="1800" b="0" dirty="0">
               <a:solidFill>
                 <a:srgbClr val="141414"/>
               </a:solidFill>
@@ -16705,13 +16696,6 @@
       </p:transition>
     </mc:Fallback>
   </mc:AlternateContent>
-  <p:timing>
-    <p:tnLst>
-      <p:par>
-        <p:cTn id="1" dur="indefinite" restart="never" nodeType="tmRoot"/>
-      </p:par>
-    </p:tnLst>
-  </p:timing>
 </p:sld>
 </file>
 
@@ -16928,19 +16912,10 @@
                 </a:solidFill>
                 <a:latin typeface="Arial"/>
               </a:rPr>
-              <a:t>Digital complaints, FIR records, tracking, </a:t>
+              <a:t>Digital complaints, FIR records, tracking, assignment</a:t>
             </a:r>
             <a:r>
-              <a:rPr sz="1600" b="0" dirty="0" smtClean="0">
-                <a:solidFill>
-                  <a:srgbClr val="141414"/>
-                </a:solidFill>
-                <a:latin typeface="Arial"/>
-              </a:rPr>
-              <a:t>assignment</a:t>
-            </a:r>
-            <a:r>
-              <a:rPr lang="en-US" sz="1600" b="0" dirty="0" smtClean="0">
+              <a:rPr lang="en-US" sz="1600" b="0" dirty="0">
                 <a:solidFill>
                   <a:srgbClr val="141414"/>
                 </a:solidFill>
@@ -16949,22 +16924,13 @@
               <a:t> and</a:t>
             </a:r>
             <a:r>
-              <a:rPr sz="1600" b="0" dirty="0" smtClean="0">
+              <a:rPr sz="1600" b="0" dirty="0">
                 <a:solidFill>
                   <a:srgbClr val="141414"/>
                 </a:solidFill>
                 <a:latin typeface="Arial"/>
               </a:rPr>
-              <a:t> </a:t>
-            </a:r>
-            <a:r>
-              <a:rPr sz="1600" b="0" dirty="0">
-                <a:solidFill>
-                  <a:srgbClr val="141414"/>
-                </a:solidFill>
-                <a:latin typeface="Arial"/>
-              </a:rPr>
-              <a:t>supervisory monitoring already exist.</a:t>
+              <a:t> supervisory monitoring already exist.</a:t>
             </a:r>
           </a:p>
         </p:txBody>
@@ -17323,19 +17289,10 @@
                 </a:solidFill>
                 <a:latin typeface="Arial"/>
               </a:rPr>
-              <a:t>Research focus: strengthen integrity verification, </a:t>
+              <a:t>Research focus: strengthen integrity verification, traceability</a:t>
             </a:r>
             <a:r>
-              <a:rPr sz="1400" b="1" dirty="0" smtClean="0">
-                <a:solidFill>
-                  <a:srgbClr val="1F497D"/>
-                </a:solidFill>
-                <a:latin typeface="Arial"/>
-              </a:rPr>
-              <a:t>traceability</a:t>
-            </a:r>
-            <a:r>
-              <a:rPr lang="en-US" sz="1400" b="1" dirty="0" smtClean="0">
+              <a:rPr lang="en-US" sz="1400" b="1" dirty="0">
                 <a:solidFill>
                   <a:srgbClr val="1F497D"/>
                 </a:solidFill>
@@ -17344,22 +17301,13 @@
               <a:t> and</a:t>
             </a:r>
             <a:r>
-              <a:rPr sz="1400" b="1" dirty="0" smtClean="0">
+              <a:rPr sz="1400" b="1" dirty="0">
                 <a:solidFill>
                   <a:srgbClr val="1F497D"/>
                 </a:solidFill>
                 <a:latin typeface="Arial"/>
               </a:rPr>
-              <a:t> </a:t>
-            </a:r>
-            <a:r>
-              <a:rPr sz="1400" b="1" dirty="0">
-                <a:solidFill>
-                  <a:srgbClr val="1F497D"/>
-                </a:solidFill>
-                <a:latin typeface="Arial"/>
-              </a:rPr>
-              <a:t>tamper evident auditing.</a:t>
+              <a:t> tamper evident auditing.</a:t>
             </a:r>
           </a:p>
         </p:txBody>
@@ -17372,13 +17320,6 @@
   <p:transition spd="slow">
     <p:randomBar dir="vert"/>
   </p:transition>
-  <p:timing>
-    <p:tnLst>
-      <p:par>
-        <p:cTn id="1" dur="indefinite" restart="never" nodeType="tmRoot"/>
-      </p:par>
-    </p:tnLst>
-  </p:timing>
 </p:sld>
 </file>
 
@@ -17457,13 +17398,6 @@
       </p:transition>
     </mc:Fallback>
   </mc:AlternateContent>
-  <p:timing>
-    <p:tnLst>
-      <p:par>
-        <p:cTn id="1" dur="indefinite" restart="never" nodeType="tmRoot"/>
-      </p:par>
-    </p:tnLst>
-  </p:timing>
 </p:sld>
 </file>
 
@@ -17559,19 +17493,10 @@
                 </a:solidFill>
                 <a:latin typeface="Arial"/>
               </a:rPr>
-              <a:t>Centralized police information systems rely on trusted administrators and application level audit logs. The project needs a way to verify who changed a record, when it </a:t>
+              <a:t>Centralized police information systems rely on trusted administrators and application level audit logs. The project needs a way to verify who changed a record, when it changed</a:t>
             </a:r>
             <a:r>
-              <a:rPr sz="1800" b="0" dirty="0" smtClean="0">
-                <a:solidFill>
-                  <a:srgbClr val="141414"/>
-                </a:solidFill>
-                <a:latin typeface="Arial"/>
-              </a:rPr>
-              <a:t>changed</a:t>
-            </a:r>
-            <a:r>
-              <a:rPr lang="en-US" sz="1800" b="0" dirty="0" smtClean="0">
+              <a:rPr lang="en-US" sz="1800" b="0" dirty="0">
                 <a:solidFill>
                   <a:srgbClr val="141414"/>
                 </a:solidFill>
@@ -17580,22 +17505,13 @@
               <a:t> and</a:t>
             </a:r>
             <a:r>
-              <a:rPr sz="1800" b="0" dirty="0" smtClean="0">
+              <a:rPr sz="1800" b="0" dirty="0">
                 <a:solidFill>
                   <a:srgbClr val="141414"/>
                 </a:solidFill>
                 <a:latin typeface="Arial"/>
               </a:rPr>
-              <a:t> </a:t>
-            </a:r>
-            <a:r>
-              <a:rPr sz="1800" b="0" dirty="0">
-                <a:solidFill>
-                  <a:srgbClr val="141414"/>
-                </a:solidFill>
-                <a:latin typeface="Arial"/>
-              </a:rPr>
-              <a:t>whether related documents were altered.</a:t>
+              <a:t> whether related documents were altered.</a:t>
             </a:r>
           </a:p>
         </p:txBody>
@@ -17671,16 +17587,10 @@
               </a:defRPr>
             </a:pPr>
             <a:r>
-              <a:rPr sz="1600" dirty="0" smtClean="0">
+              <a:rPr sz="1600" dirty="0">
                 <a:latin typeface="Arial"/>
               </a:rPr>
-              <a:t>Create </a:t>
-            </a:r>
-            <a:r>
-              <a:rPr sz="1600" dirty="0">
-                <a:latin typeface="Arial"/>
-              </a:rPr>
-              <a:t>a role based digital FIR interface</a:t>
+              <a:t>Create a role based digital FIR interface</a:t>
             </a:r>
           </a:p>
           <a:p>
@@ -17698,16 +17608,10 @@
               </a:defRPr>
             </a:pPr>
             <a:r>
-              <a:rPr sz="1600" dirty="0" smtClean="0">
+              <a:rPr sz="1600" dirty="0">
                 <a:latin typeface="Arial"/>
               </a:rPr>
-              <a:t>Secure </a:t>
-            </a:r>
-            <a:r>
-              <a:rPr sz="1600" dirty="0">
-                <a:latin typeface="Arial"/>
-              </a:rPr>
-              <a:t>authentication and backend authorization</a:t>
+              <a:t>Secure authentication and backend authorization</a:t>
             </a:r>
           </a:p>
           <a:p>
@@ -17725,7 +17629,7 @@
               </a:defRPr>
             </a:pPr>
             <a:r>
-              <a:rPr sz="1600" dirty="0" smtClean="0">
+              <a:rPr sz="1600" dirty="0">
                 <a:latin typeface="Arial"/>
               </a:rPr>
               <a:t>Integrate </a:t>
@@ -17767,16 +17671,10 @@
               </a:defRPr>
             </a:pPr>
             <a:r>
-              <a:rPr sz="1600" dirty="0" smtClean="0">
+              <a:rPr sz="1600" dirty="0">
                 <a:latin typeface="Arial"/>
               </a:rPr>
-              <a:t>Use </a:t>
-            </a:r>
-            <a:r>
-              <a:rPr sz="1600" dirty="0">
-                <a:latin typeface="Arial"/>
-              </a:rPr>
-              <a:t>SHA 256 for record and document integrity</a:t>
+              <a:t>Use SHA 256 for record and document integrity</a:t>
             </a:r>
           </a:p>
           <a:p>
@@ -17794,16 +17692,10 @@
               </a:defRPr>
             </a:pPr>
             <a:r>
-              <a:rPr sz="1600" dirty="0" smtClean="0">
+              <a:rPr sz="1600" dirty="0">
                 <a:latin typeface="Arial"/>
               </a:rPr>
-              <a:t>Track </a:t>
-            </a:r>
-            <a:r>
-              <a:rPr sz="1600" dirty="0">
-                <a:latin typeface="Arial"/>
-              </a:rPr>
-              <a:t>FIRs from registration to closure</a:t>
+              <a:t>Track FIRs from registration to closure</a:t>
             </a:r>
           </a:p>
         </p:txBody>
@@ -17844,16 +17736,10 @@
               </a:defRPr>
             </a:pPr>
             <a:r>
-              <a:rPr sz="1600" dirty="0" smtClean="0">
+              <a:rPr sz="1600" dirty="0">
                 <a:latin typeface="Arial"/>
               </a:rPr>
-              <a:t>Maintain </a:t>
-            </a:r>
-            <a:r>
-              <a:rPr sz="1600" dirty="0">
-                <a:latin typeface="Arial"/>
-              </a:rPr>
-              <a:t>a chronological audit history</a:t>
+              <a:t>Maintain a chronological audit history</a:t>
             </a:r>
           </a:p>
           <a:p>
@@ -17871,16 +17757,10 @@
               </a:defRPr>
             </a:pPr>
             <a:r>
-              <a:rPr sz="1600" dirty="0" smtClean="0">
+              <a:rPr sz="1600" dirty="0">
                 <a:latin typeface="Arial"/>
               </a:rPr>
-              <a:t>Register </a:t>
-            </a:r>
-            <a:r>
-              <a:rPr sz="1600" dirty="0">
-                <a:latin typeface="Arial"/>
-              </a:rPr>
-              <a:t>evidence metadata and hashes</a:t>
+              <a:t>Register evidence metadata and hashes</a:t>
             </a:r>
           </a:p>
           <a:p>
@@ -17898,16 +17778,10 @@
               </a:defRPr>
             </a:pPr>
             <a:r>
-              <a:rPr sz="1600" dirty="0" smtClean="0">
+              <a:rPr sz="1600" dirty="0">
                 <a:latin typeface="Arial"/>
               </a:rPr>
-              <a:t>Provide </a:t>
-            </a:r>
-            <a:r>
-              <a:rPr sz="1600" dirty="0">
-                <a:latin typeface="Arial"/>
-              </a:rPr>
-              <a:t>dashboards and reports</a:t>
+              <a:t>Provide dashboards and reports</a:t>
             </a:r>
           </a:p>
           <a:p>
@@ -17925,16 +17799,10 @@
               </a:defRPr>
             </a:pPr>
             <a:r>
-              <a:rPr sz="1600" dirty="0" smtClean="0">
+              <a:rPr sz="1600" dirty="0">
                 <a:latin typeface="Arial"/>
               </a:rPr>
-              <a:t>Notify </a:t>
-            </a:r>
-            <a:r>
-              <a:rPr sz="1600" dirty="0">
-                <a:latin typeface="Arial"/>
-              </a:rPr>
-              <a:t>users about important workflow events</a:t>
+              <a:t>Notify users about important workflow events</a:t>
             </a:r>
           </a:p>
           <a:p>
@@ -17952,16 +17820,10 @@
               </a:defRPr>
             </a:pPr>
             <a:r>
-              <a:rPr sz="1600" dirty="0" smtClean="0">
+              <a:rPr sz="1600" dirty="0">
                 <a:latin typeface="Arial"/>
               </a:rPr>
-              <a:t>Protect </a:t>
-            </a:r>
-            <a:r>
-              <a:rPr sz="1600" dirty="0">
-                <a:latin typeface="Arial"/>
-              </a:rPr>
-              <a:t>confidential information with controlled access</a:t>
+              <a:t>Protect confidential information with controlled access</a:t>
             </a:r>
           </a:p>
         </p:txBody>
@@ -17983,13 +17845,6 @@
       </p:transition>
     </mc:Fallback>
   </mc:AlternateContent>
-  <p:timing>
-    <p:tnLst>
-      <p:par>
-        <p:cTn id="1" dur="indefinite" restart="never" nodeType="tmRoot"/>
-      </p:par>
-    </p:tnLst>
-  </p:timing>
 </p:sld>
 </file>
 
@@ -18068,13 +17923,6 @@
       </p:transition>
     </mc:Fallback>
   </mc:AlternateContent>
-  <p:timing>
-    <p:tnLst>
-      <p:par>
-        <p:cTn id="1" dur="indefinite" restart="never" nodeType="tmRoot"/>
-      </p:par>
-    </p:tnLst>
-  </p:timing>
 </p:sld>
 </file>
 
@@ -18291,28 +18139,12 @@
               <a:buChar char="•"/>
             </a:pPr>
             <a:r>
-              <a:rPr sz="1600" b="0" dirty="0" smtClean="0">
+              <a:rPr sz="1600" b="0" dirty="0">
                 <a:solidFill>
                   <a:srgbClr val="141414"/>
                 </a:solidFill>
               </a:rPr>
-              <a:t>Complainant </a:t>
-            </a:r>
-            <a:r>
-              <a:rPr sz="1600" b="0" dirty="0">
-                <a:solidFill>
-                  <a:srgbClr val="141414"/>
-                </a:solidFill>
-              </a:rPr>
-              <a:t>personal </a:t>
-            </a:r>
-            <a:r>
-              <a:rPr sz="1600" b="0" dirty="0" smtClean="0">
-                <a:solidFill>
-                  <a:srgbClr val="141414"/>
-                </a:solidFill>
-              </a:rPr>
-              <a:t>data</a:t>
+              <a:t>Complainant personal data</a:t>
             </a:r>
             <a:endParaRPr lang="en-US" sz="1600" dirty="0"/>
           </a:p>
@@ -18325,28 +18157,12 @@
               <a:buChar char="•"/>
             </a:pPr>
             <a:r>
-              <a:rPr sz="1600" b="0" dirty="0" smtClean="0">
+              <a:rPr sz="1600" b="0" dirty="0">
                 <a:solidFill>
                   <a:srgbClr val="141414"/>
                 </a:solidFill>
               </a:rPr>
-              <a:t>CNIC </a:t>
-            </a:r>
-            <a:r>
-              <a:rPr sz="1600" b="0" dirty="0">
-                <a:solidFill>
-                  <a:srgbClr val="141414"/>
-                </a:solidFill>
-              </a:rPr>
-              <a:t>and contact </a:t>
-            </a:r>
-            <a:r>
-              <a:rPr sz="1600" b="0" dirty="0" smtClean="0">
-                <a:solidFill>
-                  <a:srgbClr val="141414"/>
-                </a:solidFill>
-              </a:rPr>
-              <a:t>information</a:t>
+              <a:t>CNIC and contact information</a:t>
             </a:r>
             <a:endParaRPr lang="en-US" sz="1600" dirty="0"/>
           </a:p>
@@ -18359,7 +18175,7 @@
               <a:buChar char="•"/>
             </a:pPr>
             <a:r>
-              <a:rPr sz="1600" b="0" dirty="0" smtClean="0">
+              <a:rPr sz="1600" b="0" dirty="0">
                 <a:solidFill>
                   <a:srgbClr val="141414"/>
                 </a:solidFill>
@@ -18377,28 +18193,12 @@
               <a:buChar char="•"/>
             </a:pPr>
             <a:r>
-              <a:rPr sz="1600" b="0" dirty="0" smtClean="0">
+              <a:rPr sz="1600" b="0" dirty="0">
                 <a:solidFill>
                   <a:srgbClr val="141414"/>
                 </a:solidFill>
               </a:rPr>
-              <a:t>Suspect </a:t>
-            </a:r>
-            <a:r>
-              <a:rPr sz="1600" b="0" dirty="0">
-                <a:solidFill>
-                  <a:srgbClr val="141414"/>
-                </a:solidFill>
-              </a:rPr>
-              <a:t>and witness </a:t>
-            </a:r>
-            <a:r>
-              <a:rPr sz="1600" b="0" dirty="0" smtClean="0">
-                <a:solidFill>
-                  <a:srgbClr val="141414"/>
-                </a:solidFill>
-              </a:rPr>
-              <a:t>information</a:t>
+              <a:t>Suspect and witness information</a:t>
             </a:r>
             <a:endParaRPr lang="en-US" sz="1600" dirty="0"/>
           </a:p>
@@ -18411,7 +18211,7 @@
               <a:buChar char="•"/>
             </a:pPr>
             <a:r>
-              <a:rPr sz="1600" b="0" dirty="0" smtClean="0">
+              <a:rPr sz="1600" b="0" dirty="0">
                 <a:solidFill>
                   <a:srgbClr val="141414"/>
                 </a:solidFill>
@@ -18429,31 +18229,15 @@
               <a:buChar char="•"/>
             </a:pPr>
             <a:r>
-              <a:rPr sz="1600" b="0" dirty="0" smtClean="0">
+              <a:rPr sz="1600" b="0" dirty="0">
                 <a:solidFill>
                   <a:srgbClr val="141414"/>
                 </a:solidFill>
               </a:rPr>
-              <a:t>Documents</a:t>
+              <a:t>Documents, images</a:t>
             </a:r>
             <a:r>
-              <a:rPr sz="1600" b="0" dirty="0">
-                <a:solidFill>
-                  <a:srgbClr val="141414"/>
-                </a:solidFill>
-              </a:rPr>
-              <a:t>, </a:t>
-            </a:r>
-            <a:r>
-              <a:rPr sz="1600" b="0" dirty="0" smtClean="0">
-                <a:solidFill>
-                  <a:srgbClr val="141414"/>
-                </a:solidFill>
-              </a:rPr>
-              <a:t>images</a:t>
-            </a:r>
-            <a:r>
-              <a:rPr lang="en-US" sz="1600" b="0" dirty="0" smtClean="0">
+              <a:rPr lang="en-US" sz="1600" b="0" dirty="0">
                 <a:solidFill>
                   <a:srgbClr val="141414"/>
                 </a:solidFill>
@@ -18461,32 +18245,16 @@
               <a:t> and</a:t>
             </a:r>
             <a:r>
-              <a:rPr sz="1600" b="0" dirty="0" smtClean="0">
+              <a:rPr sz="1600" b="0" dirty="0">
                 <a:solidFill>
                   <a:srgbClr val="141414"/>
                 </a:solidFill>
               </a:rPr>
-              <a:t> </a:t>
-            </a:r>
-            <a:r>
-              <a:rPr sz="1600" b="0" dirty="0">
-                <a:solidFill>
-                  <a:srgbClr val="141414"/>
-                </a:solidFill>
-              </a:rPr>
-              <a:t>PDFs</a:t>
-            </a:r>
-            <a:r>
-              <a:rPr sz="1600" dirty="0"/>
-              <a:t/>
+              <a:t> PDFs</a:t>
             </a:r>
             <a:br>
               <a:rPr sz="1600" dirty="0"/>
             </a:br>
-            <a:r>
-              <a:rPr sz="1600" dirty="0"/>
-              <a:t/>
-            </a:r>
             <a:br>
               <a:rPr sz="1600" dirty="0"/>
             </a:br>
@@ -18743,14 +18511,14 @@
               <a:buChar char="•"/>
             </a:pPr>
             <a:r>
-              <a:rPr sz="1600" b="0" dirty="0" smtClean="0">
+              <a:rPr sz="1600" b="0" dirty="0">
                 <a:solidFill>
                   <a:srgbClr val="141414"/>
                 </a:solidFill>
               </a:rPr>
               <a:t>FIR identifier</a:t>
             </a:r>
-            <a:endParaRPr lang="en-US" sz="1600" dirty="0" smtClean="0"/>
+            <a:endParaRPr lang="en-US" sz="1600" dirty="0"/>
           </a:p>
           <a:p>
             <a:pPr marL="285750" indent="-285750" algn="l">
@@ -18761,14 +18529,14 @@
               <a:buChar char="•"/>
             </a:pPr>
             <a:r>
-              <a:rPr sz="1600" b="0" dirty="0" smtClean="0">
+              <a:rPr sz="1600" b="0" dirty="0">
                 <a:solidFill>
                   <a:srgbClr val="141414"/>
                 </a:solidFill>
               </a:rPr>
               <a:t>Transaction identifier</a:t>
             </a:r>
-            <a:endParaRPr lang="en-US" sz="1600" dirty="0" smtClean="0"/>
+            <a:endParaRPr lang="en-US" sz="1600" dirty="0"/>
           </a:p>
           <a:p>
             <a:pPr marL="285750" indent="-285750" algn="l">
@@ -18779,30 +18547,14 @@
               <a:buChar char="•"/>
             </a:pPr>
             <a:r>
-              <a:rPr sz="1600" b="0" dirty="0" smtClean="0">
+              <a:rPr sz="1600" b="0" dirty="0">
                 <a:solidFill>
                   <a:srgbClr val="141414"/>
                 </a:solidFill>
               </a:rPr>
-              <a:t>Record </a:t>
+              <a:t>Record and document hashes</a:t>
             </a:r>
-            <a:r>
-              <a:rPr sz="1600" b="0" dirty="0">
-                <a:solidFill>
-                  <a:srgbClr val="141414"/>
-                </a:solidFill>
-              </a:rPr>
-              <a:t>and document </a:t>
-            </a:r>
-            <a:r>
-              <a:rPr sz="1600" b="0" dirty="0" smtClean="0">
-                <a:solidFill>
-                  <a:srgbClr val="141414"/>
-                </a:solidFill>
-              </a:rPr>
-              <a:t>hashes</a:t>
-            </a:r>
-            <a:endParaRPr lang="en-US" sz="1600" dirty="0" smtClean="0"/>
+            <a:endParaRPr lang="en-US" sz="1600" dirty="0"/>
           </a:p>
           <a:p>
             <a:pPr marL="285750" indent="-285750" algn="l">
@@ -18813,30 +18565,14 @@
               <a:buChar char="•"/>
             </a:pPr>
             <a:r>
-              <a:rPr sz="1600" b="0" dirty="0" smtClean="0">
+              <a:rPr sz="1600" b="0" dirty="0">
                 <a:solidFill>
                   <a:srgbClr val="141414"/>
                 </a:solidFill>
               </a:rPr>
-              <a:t>Operation </a:t>
+              <a:t>Operation type and status</a:t>
             </a:r>
-            <a:r>
-              <a:rPr sz="1600" b="0" dirty="0">
-                <a:solidFill>
-                  <a:srgbClr val="141414"/>
-                </a:solidFill>
-              </a:rPr>
-              <a:t>type and </a:t>
-            </a:r>
-            <a:r>
-              <a:rPr sz="1600" b="0" dirty="0" smtClean="0">
-                <a:solidFill>
-                  <a:srgbClr val="141414"/>
-                </a:solidFill>
-              </a:rPr>
-              <a:t>status</a:t>
-            </a:r>
-            <a:endParaRPr lang="en-US" sz="1600" dirty="0" smtClean="0"/>
+            <a:endParaRPr lang="en-US" sz="1600" dirty="0"/>
           </a:p>
           <a:p>
             <a:pPr marL="285750" indent="-285750" algn="l">
@@ -18847,30 +18583,14 @@
               <a:buChar char="•"/>
             </a:pPr>
             <a:r>
-              <a:rPr sz="1600" b="0" dirty="0" smtClean="0">
+              <a:rPr sz="1600" b="0" dirty="0">
                 <a:solidFill>
                   <a:srgbClr val="141414"/>
                 </a:solidFill>
               </a:rPr>
-              <a:t>Officer </a:t>
+              <a:t>Officer / organization identifier</a:t>
             </a:r>
-            <a:r>
-              <a:rPr sz="1600" b="0" dirty="0">
-                <a:solidFill>
-                  <a:srgbClr val="141414"/>
-                </a:solidFill>
-              </a:rPr>
-              <a:t>/ organization </a:t>
-            </a:r>
-            <a:r>
-              <a:rPr sz="1600" b="0" dirty="0" smtClean="0">
-                <a:solidFill>
-                  <a:srgbClr val="141414"/>
-                </a:solidFill>
-              </a:rPr>
-              <a:t>identifier</a:t>
-            </a:r>
-            <a:endParaRPr lang="en-US" sz="1600" dirty="0" smtClean="0"/>
+            <a:endParaRPr lang="en-US" sz="1600" dirty="0"/>
           </a:p>
           <a:p>
             <a:pPr marL="285750" indent="-285750" algn="l">
@@ -18881,30 +18601,14 @@
               <a:buChar char="•"/>
             </a:pPr>
             <a:r>
-              <a:rPr sz="1600" b="0" dirty="0" smtClean="0">
+              <a:rPr sz="1600" b="0" dirty="0">
                 <a:solidFill>
                   <a:srgbClr val="141414"/>
                 </a:solidFill>
               </a:rPr>
-              <a:t>Timestamp </a:t>
+              <a:t>Timestamp and workflow state</a:t>
             </a:r>
-            <a:r>
-              <a:rPr sz="1600" b="0" dirty="0">
-                <a:solidFill>
-                  <a:srgbClr val="141414"/>
-                </a:solidFill>
-              </a:rPr>
-              <a:t>and workflow </a:t>
-            </a:r>
-            <a:r>
-              <a:rPr sz="1600" b="0" dirty="0" smtClean="0">
-                <a:solidFill>
-                  <a:srgbClr val="141414"/>
-                </a:solidFill>
-              </a:rPr>
-              <a:t>state</a:t>
-            </a:r>
-            <a:endParaRPr lang="en-US" sz="1600" dirty="0" smtClean="0"/>
+            <a:endParaRPr lang="en-US" sz="1600" dirty="0"/>
           </a:p>
           <a:p>
             <a:pPr marL="285750" indent="-285750" algn="l">
@@ -18915,32 +18619,16 @@
               <a:buChar char="•"/>
             </a:pPr>
             <a:r>
-              <a:rPr sz="1600" b="0" dirty="0" smtClean="0">
+              <a:rPr sz="1600" b="0" dirty="0">
                 <a:solidFill>
                   <a:srgbClr val="141414"/>
                 </a:solidFill>
               </a:rPr>
-              <a:t>Approval </a:t>
-            </a:r>
-            <a:r>
-              <a:rPr sz="1600" b="0" dirty="0">
-                <a:solidFill>
-                  <a:srgbClr val="141414"/>
-                </a:solidFill>
-              </a:rPr>
-              <a:t>and audit events</a:t>
-            </a:r>
-            <a:r>
-              <a:rPr sz="1600" dirty="0"/>
-              <a:t/>
+              <a:t>Approval and audit events</a:t>
             </a:r>
             <a:br>
               <a:rPr sz="1600" dirty="0"/>
             </a:br>
-            <a:r>
-              <a:rPr sz="1600" dirty="0"/>
-              <a:t/>
-            </a:r>
             <a:br>
               <a:rPr sz="1600" dirty="0"/>
             </a:br>
@@ -19031,13 +18719,6 @@
       </p:transition>
     </mc:Fallback>
   </mc:AlternateContent>
-  <p:timing>
-    <p:tnLst>
-      <p:par>
-        <p:cTn id="1" dur="indefinite" restart="never" nodeType="tmRoot"/>
-      </p:par>
-    </p:tnLst>
-  </p:timing>
 </p:sld>
 </file>
 
@@ -20032,13 +19713,6 @@
       </p:transition>
     </mc:Fallback>
   </mc:AlternateContent>
-  <p:timing>
-    <p:tnLst>
-      <p:par>
-        <p:cTn id="1" dur="indefinite" restart="never" nodeType="tmRoot"/>
-      </p:par>
-    </p:tnLst>
-  </p:timing>
 </p:sld>
 </file>
 
@@ -20117,13 +19791,6 @@
       </p:transition>
     </mc:Fallback>
   </mc:AlternateContent>
-  <p:timing>
-    <p:tnLst>
-      <p:par>
-        <p:cTn id="1" dur="indefinite" restart="never" nodeType="tmRoot"/>
-      </p:par>
-    </p:tnLst>
-  </p:timing>
 </p:sld>
 </file>
 
@@ -20340,30 +20007,14 @@
               <a:buChar char="•"/>
             </a:pPr>
             <a:r>
-              <a:rPr sz="1550" b="0" dirty="0" smtClean="0">
+              <a:rPr sz="1550" b="0" dirty="0">
                 <a:solidFill>
                   <a:srgbClr val="141414"/>
                 </a:solidFill>
               </a:rPr>
-              <a:t>Authentication </a:t>
+              <a:t>Authentication and identity</a:t>
             </a:r>
-            <a:r>
-              <a:rPr sz="1550" b="0" dirty="0">
-                <a:solidFill>
-                  <a:srgbClr val="141414"/>
-                </a:solidFill>
-              </a:rPr>
-              <a:t>and </a:t>
-            </a:r>
-            <a:r>
-              <a:rPr sz="1550" b="0" dirty="0" smtClean="0">
-                <a:solidFill>
-                  <a:srgbClr val="141414"/>
-                </a:solidFill>
-              </a:rPr>
-              <a:t>identity</a:t>
-            </a:r>
-            <a:endParaRPr lang="en-US" sz="1550" dirty="0" smtClean="0"/>
+            <a:endParaRPr lang="en-US" sz="1550" dirty="0"/>
           </a:p>
           <a:p>
             <a:pPr marL="285750" indent="-285750" algn="l">
@@ -20374,30 +20025,14 @@
               <a:buChar char="•"/>
             </a:pPr>
             <a:r>
-              <a:rPr sz="1550" b="0" dirty="0" smtClean="0">
+              <a:rPr sz="1550" b="0" dirty="0">
                 <a:solidFill>
                   <a:srgbClr val="141414"/>
                 </a:solidFill>
               </a:rPr>
-              <a:t>Citizen </a:t>
+              <a:t>Citizen complaint portal</a:t>
             </a:r>
-            <a:r>
-              <a:rPr sz="1550" b="0" dirty="0">
-                <a:solidFill>
-                  <a:srgbClr val="141414"/>
-                </a:solidFill>
-              </a:rPr>
-              <a:t>complaint </a:t>
-            </a:r>
-            <a:r>
-              <a:rPr sz="1550" b="0" dirty="0" smtClean="0">
-                <a:solidFill>
-                  <a:srgbClr val="141414"/>
-                </a:solidFill>
-              </a:rPr>
-              <a:t>portal</a:t>
-            </a:r>
-            <a:endParaRPr lang="en-US" sz="1550" dirty="0" smtClean="0"/>
+            <a:endParaRPr lang="en-US" sz="1550" dirty="0"/>
           </a:p>
           <a:p>
             <a:pPr marL="285750" indent="-285750" algn="l">
@@ -20408,30 +20043,14 @@
               <a:buChar char="•"/>
             </a:pPr>
             <a:r>
-              <a:rPr sz="1550" b="0" dirty="0" smtClean="0">
+              <a:rPr sz="1550" b="0" dirty="0">
                 <a:solidFill>
                   <a:srgbClr val="141414"/>
                 </a:solidFill>
               </a:rPr>
-              <a:t>FIR </a:t>
+              <a:t>FIR creation, approval, tracking</a:t>
             </a:r>
-            <a:r>
-              <a:rPr sz="1550" b="0" dirty="0">
-                <a:solidFill>
-                  <a:srgbClr val="141414"/>
-                </a:solidFill>
-              </a:rPr>
-              <a:t>creation, approval, </a:t>
-            </a:r>
-            <a:r>
-              <a:rPr sz="1550" b="0" dirty="0" smtClean="0">
-                <a:solidFill>
-                  <a:srgbClr val="141414"/>
-                </a:solidFill>
-              </a:rPr>
-              <a:t>tracking</a:t>
-            </a:r>
-            <a:endParaRPr lang="en-US" sz="1550" dirty="0" smtClean="0"/>
+            <a:endParaRPr lang="en-US" sz="1550" dirty="0"/>
           </a:p>
           <a:p>
             <a:pPr marL="285750" indent="-285750" algn="l">
@@ -20442,30 +20061,14 @@
               <a:buChar char="•"/>
             </a:pPr>
             <a:r>
-              <a:rPr sz="1550" b="0" dirty="0" smtClean="0">
+              <a:rPr sz="1550" b="0" dirty="0">
                 <a:solidFill>
                   <a:srgbClr val="141414"/>
                 </a:solidFill>
               </a:rPr>
-              <a:t>Police </a:t>
+              <a:t>Police station management</a:t>
             </a:r>
-            <a:r>
-              <a:rPr sz="1550" b="0" dirty="0">
-                <a:solidFill>
-                  <a:srgbClr val="141414"/>
-                </a:solidFill>
-              </a:rPr>
-              <a:t>station </a:t>
-            </a:r>
-            <a:r>
-              <a:rPr sz="1550" b="0" dirty="0" smtClean="0">
-                <a:solidFill>
-                  <a:srgbClr val="141414"/>
-                </a:solidFill>
-              </a:rPr>
-              <a:t>management</a:t>
-            </a:r>
-            <a:endParaRPr lang="en-US" sz="1550" dirty="0" smtClean="0"/>
+            <a:endParaRPr lang="en-US" sz="1550" dirty="0"/>
           </a:p>
           <a:p>
             <a:pPr marL="285750" indent="-285750" algn="l">
@@ -20476,30 +20079,14 @@
               <a:buChar char="•"/>
             </a:pPr>
             <a:r>
-              <a:rPr sz="1550" b="0" dirty="0" smtClean="0">
+              <a:rPr sz="1550" b="0" dirty="0">
                 <a:solidFill>
                   <a:srgbClr val="141414"/>
                 </a:solidFill>
               </a:rPr>
-              <a:t>Investigation </a:t>
+              <a:t>Investigation and officer assignment</a:t>
             </a:r>
-            <a:r>
-              <a:rPr sz="1550" b="0" dirty="0">
-                <a:solidFill>
-                  <a:srgbClr val="141414"/>
-                </a:solidFill>
-              </a:rPr>
-              <a:t>and officer </a:t>
-            </a:r>
-            <a:r>
-              <a:rPr sz="1550" b="0" dirty="0" smtClean="0">
-                <a:solidFill>
-                  <a:srgbClr val="141414"/>
-                </a:solidFill>
-              </a:rPr>
-              <a:t>assignment</a:t>
-            </a:r>
-            <a:endParaRPr lang="en-US" sz="1550" dirty="0" smtClean="0"/>
+            <a:endParaRPr lang="en-US" sz="1550" dirty="0"/>
           </a:p>
           <a:p>
             <a:pPr marL="285750" indent="-285750" algn="l">
@@ -20510,30 +20097,14 @@
               <a:buChar char="•"/>
             </a:pPr>
             <a:r>
-              <a:rPr sz="1550" b="0" dirty="0" smtClean="0">
+              <a:rPr sz="1550" b="0" dirty="0">
                 <a:solidFill>
                   <a:srgbClr val="141414"/>
                 </a:solidFill>
               </a:rPr>
-              <a:t>Evidence </a:t>
+              <a:t>Evidence and SHA 256 hashing</a:t>
             </a:r>
-            <a:r>
-              <a:rPr sz="1550" b="0" dirty="0">
-                <a:solidFill>
-                  <a:srgbClr val="141414"/>
-                </a:solidFill>
-              </a:rPr>
-              <a:t>and SHA 256 </a:t>
-            </a:r>
-            <a:r>
-              <a:rPr sz="1550" b="0" dirty="0" smtClean="0">
-                <a:solidFill>
-                  <a:srgbClr val="141414"/>
-                </a:solidFill>
-              </a:rPr>
-              <a:t>hashing</a:t>
-            </a:r>
-            <a:endParaRPr lang="en-US" sz="1550" dirty="0" smtClean="0"/>
+            <a:endParaRPr lang="en-US" sz="1550" dirty="0"/>
           </a:p>
           <a:p>
             <a:pPr marL="285750" indent="-285750" algn="l">
@@ -20544,7 +20115,7 @@
               <a:buChar char="•"/>
             </a:pPr>
             <a:r>
-              <a:rPr sz="1550" b="0" dirty="0" err="1" smtClean="0">
+              <a:rPr sz="1550" b="0" dirty="0" err="1">
                 <a:solidFill>
                   <a:srgbClr val="141414"/>
                 </a:solidFill>
@@ -20552,30 +20123,14 @@
               <a:t>Hyperledger</a:t>
             </a:r>
             <a:r>
-              <a:rPr sz="1550" b="0" dirty="0" smtClean="0">
+              <a:rPr sz="1550" b="0" dirty="0">
                 <a:solidFill>
                   <a:srgbClr val="141414"/>
                 </a:solidFill>
               </a:rPr>
-              <a:t> </a:t>
+              <a:t> Fabric transactions</a:t>
             </a:r>
-            <a:r>
-              <a:rPr sz="1550" b="0" dirty="0">
-                <a:solidFill>
-                  <a:srgbClr val="141414"/>
-                </a:solidFill>
-              </a:rPr>
-              <a:t>Fabric </a:t>
-            </a:r>
-            <a:r>
-              <a:rPr sz="1550" b="0" dirty="0" smtClean="0">
-                <a:solidFill>
-                  <a:srgbClr val="141414"/>
-                </a:solidFill>
-              </a:rPr>
-              <a:t>transactions</a:t>
-            </a:r>
-            <a:endParaRPr lang="en-US" sz="1550" dirty="0" smtClean="0"/>
+            <a:endParaRPr lang="en-US" sz="1550" dirty="0"/>
           </a:p>
           <a:p>
             <a:pPr marL="285750" indent="-285750" algn="l">
@@ -20586,30 +20141,14 @@
               <a:buChar char="•"/>
             </a:pPr>
             <a:r>
-              <a:rPr sz="1550" b="0" dirty="0" smtClean="0">
+              <a:rPr sz="1550" b="0" dirty="0">
                 <a:solidFill>
                   <a:srgbClr val="141414"/>
                 </a:solidFill>
               </a:rPr>
-              <a:t>Audit </a:t>
+              <a:t>Audit trail and history</a:t>
             </a:r>
-            <a:r>
-              <a:rPr sz="1550" b="0" dirty="0">
-                <a:solidFill>
-                  <a:srgbClr val="141414"/>
-                </a:solidFill>
-              </a:rPr>
-              <a:t>trail and </a:t>
-            </a:r>
-            <a:r>
-              <a:rPr sz="1550" b="0" dirty="0" smtClean="0">
-                <a:solidFill>
-                  <a:srgbClr val="141414"/>
-                </a:solidFill>
-              </a:rPr>
-              <a:t>history</a:t>
-            </a:r>
-            <a:endParaRPr lang="en-US" sz="1550" dirty="0" smtClean="0"/>
+            <a:endParaRPr lang="en-US" sz="1550" dirty="0"/>
           </a:p>
           <a:p>
             <a:pPr marL="285750" indent="-285750" algn="l">
@@ -20620,20 +20159,12 @@
               <a:buChar char="•"/>
             </a:pPr>
             <a:r>
-              <a:rPr sz="1550" b="0" dirty="0" smtClean="0">
+              <a:rPr sz="1550" b="0" dirty="0">
                 <a:solidFill>
                   <a:srgbClr val="141414"/>
                 </a:solidFill>
               </a:rPr>
-              <a:t>Notifications</a:t>
-            </a:r>
-            <a:r>
-              <a:rPr sz="1550" b="0" dirty="0">
-                <a:solidFill>
-                  <a:srgbClr val="141414"/>
-                </a:solidFill>
-              </a:rPr>
-              <a:t>, analytics, administration</a:t>
+              <a:t>Notifications, analytics, administration</a:t>
             </a:r>
           </a:p>
         </p:txBody>
@@ -20793,30 +20324,14 @@
               <a:buChar char="•"/>
             </a:pPr>
             <a:r>
-              <a:rPr sz="1550" b="0" dirty="0" smtClean="0">
+              <a:rPr sz="1550" b="0" dirty="0">
                 <a:solidFill>
                   <a:srgbClr val="141414"/>
                 </a:solidFill>
               </a:rPr>
-              <a:t>Live </a:t>
+              <a:t>Live Pakistan Police integration</a:t>
             </a:r>
-            <a:r>
-              <a:rPr sz="1550" b="0" dirty="0">
-                <a:solidFill>
-                  <a:srgbClr val="141414"/>
-                </a:solidFill>
-              </a:rPr>
-              <a:t>Pakistan Police </a:t>
-            </a:r>
-            <a:r>
-              <a:rPr sz="1550" b="0" dirty="0" smtClean="0">
-                <a:solidFill>
-                  <a:srgbClr val="141414"/>
-                </a:solidFill>
-              </a:rPr>
-              <a:t>integration</a:t>
-            </a:r>
-            <a:endParaRPr lang="en-US" sz="1550" dirty="0" smtClean="0"/>
+            <a:endParaRPr lang="en-US" sz="1550" dirty="0"/>
           </a:p>
           <a:p>
             <a:pPr marL="285750" indent="-285750" algn="l">
@@ -20827,30 +20342,14 @@
               <a:buChar char="•"/>
             </a:pPr>
             <a:r>
-              <a:rPr sz="1550" b="0" dirty="0" smtClean="0">
+              <a:rPr sz="1550" b="0" dirty="0">
                 <a:solidFill>
                   <a:srgbClr val="141414"/>
                 </a:solidFill>
               </a:rPr>
-              <a:t>Real </a:t>
+              <a:t>Real NADRA verification</a:t>
             </a:r>
-            <a:r>
-              <a:rPr sz="1550" b="0" dirty="0">
-                <a:solidFill>
-                  <a:srgbClr val="141414"/>
-                </a:solidFill>
-              </a:rPr>
-              <a:t>NADRA </a:t>
-            </a:r>
-            <a:r>
-              <a:rPr sz="1550" b="0" dirty="0" smtClean="0">
-                <a:solidFill>
-                  <a:srgbClr val="141414"/>
-                </a:solidFill>
-              </a:rPr>
-              <a:t>verification</a:t>
-            </a:r>
-            <a:endParaRPr lang="en-US" sz="1550" dirty="0" smtClean="0"/>
+            <a:endParaRPr lang="en-US" sz="1550" dirty="0"/>
           </a:p>
           <a:p>
             <a:pPr marL="285750" indent="-285750" algn="l">
@@ -20861,30 +20360,14 @@
               <a:buChar char="•"/>
             </a:pPr>
             <a:r>
-              <a:rPr sz="1550" b="0" dirty="0" smtClean="0">
+              <a:rPr sz="1550" b="0" dirty="0">
                 <a:solidFill>
                   <a:srgbClr val="141414"/>
                 </a:solidFill>
               </a:rPr>
-              <a:t>Real </a:t>
+              <a:t>Real criminal history data</a:t>
             </a:r>
-            <a:r>
-              <a:rPr sz="1550" b="0" dirty="0">
-                <a:solidFill>
-                  <a:srgbClr val="141414"/>
-                </a:solidFill>
-              </a:rPr>
-              <a:t>criminal history </a:t>
-            </a:r>
-            <a:r>
-              <a:rPr sz="1550" b="0" dirty="0" smtClean="0">
-                <a:solidFill>
-                  <a:srgbClr val="141414"/>
-                </a:solidFill>
-              </a:rPr>
-              <a:t>data</a:t>
-            </a:r>
-            <a:endParaRPr lang="en-US" sz="1550" dirty="0" smtClean="0"/>
+            <a:endParaRPr lang="en-US" sz="1550" dirty="0"/>
           </a:p>
           <a:p>
             <a:pPr marL="285750" indent="-285750" algn="l">
@@ -20895,30 +20378,14 @@
               <a:buChar char="•"/>
             </a:pPr>
             <a:r>
-              <a:rPr sz="1550" b="0" dirty="0" smtClean="0">
+              <a:rPr sz="1550" b="0" dirty="0">
                 <a:solidFill>
                   <a:srgbClr val="141414"/>
                 </a:solidFill>
               </a:rPr>
-              <a:t>AI </a:t>
+              <a:t>AI based profiling or prediction</a:t>
             </a:r>
-            <a:r>
-              <a:rPr sz="1550" b="0" dirty="0">
-                <a:solidFill>
-                  <a:srgbClr val="141414"/>
-                </a:solidFill>
-              </a:rPr>
-              <a:t>based profiling or </a:t>
-            </a:r>
-            <a:r>
-              <a:rPr sz="1550" b="0" dirty="0" smtClean="0">
-                <a:solidFill>
-                  <a:srgbClr val="141414"/>
-                </a:solidFill>
-              </a:rPr>
-              <a:t>prediction</a:t>
-            </a:r>
-            <a:endParaRPr lang="en-US" sz="1550" dirty="0" smtClean="0"/>
+            <a:endParaRPr lang="en-US" sz="1550" dirty="0"/>
           </a:p>
           <a:p>
             <a:pPr marL="285750" indent="-285750" algn="l">
@@ -20929,14 +20396,14 @@
               <a:buChar char="•"/>
             </a:pPr>
             <a:r>
-              <a:rPr sz="1550" b="0" dirty="0" smtClean="0">
+              <a:rPr sz="1550" b="0" dirty="0">
                 <a:solidFill>
                   <a:srgbClr val="141414"/>
                 </a:solidFill>
               </a:rPr>
               <a:t>Production deployment</a:t>
             </a:r>
-            <a:endParaRPr lang="en-US" sz="1550" dirty="0" smtClean="0"/>
+            <a:endParaRPr lang="en-US" sz="1550" dirty="0"/>
           </a:p>
           <a:p>
             <a:pPr marL="285750" indent="-285750" algn="l">
@@ -20944,32 +20411,16 @@
               <a:buChar char="•"/>
             </a:pPr>
             <a:r>
-              <a:rPr sz="1550" b="0" dirty="0" smtClean="0">
+              <a:rPr sz="1550" b="0" dirty="0">
                 <a:solidFill>
                   <a:srgbClr val="141414"/>
                 </a:solidFill>
               </a:rPr>
-              <a:t>Legal </a:t>
-            </a:r>
-            <a:r>
-              <a:rPr sz="1550" b="0" dirty="0">
-                <a:solidFill>
-                  <a:srgbClr val="141414"/>
-                </a:solidFill>
-              </a:rPr>
-              <a:t>authorization of real FIRs</a:t>
-            </a:r>
-            <a:r>
-              <a:rPr sz="1550" dirty="0"/>
-              <a:t/>
+              <a:t>Legal authorization of real FIRs</a:t>
             </a:r>
             <a:br>
               <a:rPr sz="1550" dirty="0"/>
             </a:br>
-            <a:r>
-              <a:rPr sz="1550" dirty="0"/>
-              <a:t/>
-            </a:r>
             <a:br>
               <a:rPr sz="1550" dirty="0"/>
             </a:br>
@@ -21001,13 +20452,6 @@
       </p:transition>
     </mc:Fallback>
   </mc:AlternateContent>
-  <p:timing>
-    <p:tnLst>
-      <p:par>
-        <p:cTn id="1" dur="indefinite" restart="never" nodeType="tmRoot"/>
-      </p:par>
-    </p:tnLst>
-  </p:timing>
 </p:sld>
 </file>
 
@@ -21538,7 +20982,7 @@
           <a:p>
             <a:pPr algn="l"/>
             <a:r>
-              <a:rPr b="0" dirty="0" smtClean="0">
+              <a:rPr b="0" dirty="0">
                 <a:solidFill>
                   <a:srgbClr val="141414"/>
                 </a:solidFill>
@@ -21547,7 +20991,7 @@
               <a:t>Frontend, </a:t>
             </a:r>
             <a:r>
-              <a:rPr b="0" dirty="0" err="1" smtClean="0">
+              <a:rPr b="0" dirty="0" err="1">
                 <a:solidFill>
                   <a:srgbClr val="141414"/>
                 </a:solidFill>
@@ -21556,7 +21000,7 @@
               <a:t>FastAPI</a:t>
             </a:r>
             <a:r>
-              <a:rPr b="0" dirty="0" smtClean="0">
+              <a:rPr b="0" dirty="0">
                 <a:solidFill>
                   <a:srgbClr val="141414"/>
                 </a:solidFill>
@@ -21564,12 +21008,6 @@
               </a:rPr>
               <a:t> backend, authentication, FIR modules</a:t>
             </a:r>
-            <a:endParaRPr b="0" dirty="0">
-              <a:solidFill>
-                <a:srgbClr val="141414"/>
-              </a:solidFill>
-              <a:latin typeface="Arial"/>
-            </a:endParaRPr>
           </a:p>
         </p:txBody>
       </p:sp>
@@ -22123,13 +21561,6 @@
       </p:transition>
     </mc:Fallback>
   </mc:AlternateContent>
-  <p:timing>
-    <p:tnLst>
-      <p:par>
-        <p:cTn id="1" dur="indefinite" restart="never" nodeType="tmRoot"/>
-      </p:par>
-    </p:tnLst>
-  </p:timing>
 </p:sld>
 </file>
 
@@ -22331,15 +21762,7 @@
                   <a:srgbClr val="141414"/>
                 </a:solidFill>
               </a:rPr>
-              <a:t>System Architecture and Blockchain </a:t>
-            </a:r>
-            <a:r>
-              <a:rPr sz="1300" b="1" dirty="0" smtClean="0">
-                <a:solidFill>
-                  <a:srgbClr val="141414"/>
-                </a:solidFill>
-              </a:rPr>
-              <a:t>Lead</a:t>
+              <a:t>System Architecture and Blockchain Lead</a:t>
             </a:r>
             <a:endParaRPr lang="en-US" sz="1600" b="0" dirty="0">
               <a:solidFill>
@@ -22354,30 +21777,14 @@
               <a:buChar char="•"/>
             </a:pPr>
             <a:r>
-              <a:rPr b="0" dirty="0" smtClean="0">
+              <a:rPr b="0" dirty="0">
                 <a:solidFill>
                   <a:srgbClr val="141414"/>
                 </a:solidFill>
               </a:rPr>
-              <a:t>Architecture </a:t>
+              <a:t>Architecture and requirements coordination</a:t>
             </a:r>
-            <a:r>
-              <a:rPr b="0" dirty="0">
-                <a:solidFill>
-                  <a:srgbClr val="141414"/>
-                </a:solidFill>
-              </a:rPr>
-              <a:t>and requirements </a:t>
-            </a:r>
-            <a:r>
-              <a:rPr b="0" dirty="0" smtClean="0">
-                <a:solidFill>
-                  <a:srgbClr val="141414"/>
-                </a:solidFill>
-              </a:rPr>
-              <a:t>coordination</a:t>
-            </a:r>
-            <a:endParaRPr lang="en-US" dirty="0" smtClean="0"/>
+            <a:endParaRPr lang="en-US" dirty="0"/>
           </a:p>
           <a:p>
             <a:pPr marL="171450" indent="-171450" algn="l">
@@ -22385,7 +21792,7 @@
               <a:buChar char="•"/>
             </a:pPr>
             <a:r>
-              <a:rPr b="0" dirty="0" err="1" smtClean="0">
+              <a:rPr b="0" dirty="0" err="1">
                 <a:solidFill>
                   <a:srgbClr val="141414"/>
                 </a:solidFill>
@@ -22393,20 +21800,12 @@
               <a:t>Hyperledger</a:t>
             </a:r>
             <a:r>
-              <a:rPr b="0" dirty="0" smtClean="0">
+              <a:rPr b="0" dirty="0">
                 <a:solidFill>
                   <a:srgbClr val="141414"/>
                 </a:solidFill>
               </a:rPr>
-              <a:t> </a:t>
-            </a:r>
-            <a:r>
-              <a:rPr b="0" dirty="0">
-                <a:solidFill>
-                  <a:srgbClr val="141414"/>
-                </a:solidFill>
-              </a:rPr>
-              <a:t>Fabric and </a:t>
+              <a:t> Fabric and </a:t>
             </a:r>
             <a:r>
               <a:rPr b="0" dirty="0" err="1">
@@ -22422,17 +21821,9 @@
                   <a:srgbClr val="141414"/>
                 </a:solidFill>
               </a:rPr>
-              <a:t> </a:t>
+              <a:t> coordination</a:t>
             </a:r>
-            <a:r>
-              <a:rPr b="0" dirty="0" smtClean="0">
-                <a:solidFill>
-                  <a:srgbClr val="141414"/>
-                </a:solidFill>
-              </a:rPr>
-              <a:t>coordination</a:t>
-            </a:r>
-            <a:endParaRPr lang="en-US" dirty="0" smtClean="0"/>
+            <a:endParaRPr lang="en-US" dirty="0"/>
           </a:p>
           <a:p>
             <a:pPr marL="171450" indent="-171450" algn="l">
@@ -22440,30 +21831,14 @@
               <a:buChar char="•"/>
             </a:pPr>
             <a:r>
-              <a:rPr b="0" dirty="0" smtClean="0">
+              <a:rPr b="0" dirty="0">
                 <a:solidFill>
                   <a:srgbClr val="141414"/>
                 </a:solidFill>
               </a:rPr>
-              <a:t>Hash </a:t>
+              <a:t>Hash and integrity architecture</a:t>
             </a:r>
-            <a:r>
-              <a:rPr b="0" dirty="0">
-                <a:solidFill>
-                  <a:srgbClr val="141414"/>
-                </a:solidFill>
-              </a:rPr>
-              <a:t>and integrity </a:t>
-            </a:r>
-            <a:r>
-              <a:rPr b="0" dirty="0" smtClean="0">
-                <a:solidFill>
-                  <a:srgbClr val="141414"/>
-                </a:solidFill>
-              </a:rPr>
-              <a:t>architecture</a:t>
-            </a:r>
-            <a:endParaRPr lang="en-US" dirty="0" smtClean="0"/>
+            <a:endParaRPr lang="en-US" dirty="0"/>
           </a:p>
           <a:p>
             <a:pPr marL="171450" indent="-171450" algn="l">
@@ -22471,30 +21846,14 @@
               <a:buChar char="•"/>
             </a:pPr>
             <a:r>
-              <a:rPr b="0" dirty="0" smtClean="0">
+              <a:rPr b="0" dirty="0">
                 <a:solidFill>
                   <a:srgbClr val="141414"/>
                 </a:solidFill>
               </a:rPr>
-              <a:t>Security </a:t>
+              <a:t>Security architecture and integration</a:t>
             </a:r>
-            <a:r>
-              <a:rPr b="0" dirty="0">
-                <a:solidFill>
-                  <a:srgbClr val="141414"/>
-                </a:solidFill>
-              </a:rPr>
-              <a:t>architecture and </a:t>
-            </a:r>
-            <a:r>
-              <a:rPr b="0" dirty="0" smtClean="0">
-                <a:solidFill>
-                  <a:srgbClr val="141414"/>
-                </a:solidFill>
-              </a:rPr>
-              <a:t>integration</a:t>
-            </a:r>
-            <a:endParaRPr lang="en-US" dirty="0" smtClean="0"/>
+            <a:endParaRPr lang="en-US" dirty="0"/>
           </a:p>
           <a:p>
             <a:pPr marL="171450" indent="-171450" algn="l">
@@ -22502,20 +21861,12 @@
               <a:buChar char="•"/>
             </a:pPr>
             <a:r>
-              <a:rPr b="0" dirty="0" smtClean="0">
+              <a:rPr b="0" dirty="0">
                 <a:solidFill>
                   <a:srgbClr val="141414"/>
                 </a:solidFill>
               </a:rPr>
-              <a:t>GitHub </a:t>
-            </a:r>
-            <a:r>
-              <a:rPr b="0" dirty="0">
-                <a:solidFill>
-                  <a:srgbClr val="141414"/>
-                </a:solidFill>
-              </a:rPr>
-              <a:t>and deployment coordination</a:t>
+              <a:t>GitHub and deployment coordination</a:t>
             </a:r>
           </a:p>
         </p:txBody>
@@ -22674,21 +22025,13 @@
                   <a:srgbClr val="141414"/>
                 </a:solidFill>
               </a:rPr>
-              <a:t>Backend and Database </a:t>
+              <a:t>Backend and Database Lead</a:t>
             </a:r>
-            <a:r>
-              <a:rPr sz="1300" b="1" dirty="0" smtClean="0">
-                <a:solidFill>
-                  <a:srgbClr val="141414"/>
-                </a:solidFill>
-              </a:rPr>
-              <a:t>Lead</a:t>
-            </a:r>
-            <a:endParaRPr lang="en-US" sz="1300" b="1" dirty="0" smtClean="0"/>
+            <a:endParaRPr lang="en-US" sz="1300" b="1" dirty="0"/>
           </a:p>
           <a:p>
             <a:pPr algn="l"/>
-            <a:endParaRPr lang="en-US" dirty="0" smtClean="0"/>
+            <a:endParaRPr lang="en-US" dirty="0"/>
           </a:p>
           <a:p>
             <a:pPr marL="285750" indent="-285750" algn="l">
@@ -22699,30 +22042,22 @@
               <a:buChar char="•"/>
             </a:pPr>
             <a:r>
-              <a:rPr sz="1300" b="0" dirty="0" smtClean="0">
+              <a:rPr sz="1300" b="0" dirty="0">
                 <a:solidFill>
                   <a:srgbClr val="141414"/>
                 </a:solidFill>
               </a:rPr>
-              <a:t>Python </a:t>
+              <a:t>Python and </a:t>
             </a:r>
             <a:r>
-              <a:rPr sz="1300" b="0" dirty="0">
-                <a:solidFill>
-                  <a:srgbClr val="141414"/>
-                </a:solidFill>
-              </a:rPr>
-              <a:t>and </a:t>
-            </a:r>
-            <a:r>
-              <a:rPr sz="1300" b="0" dirty="0" err="1" smtClean="0">
+              <a:rPr sz="1300" b="0" dirty="0" err="1">
                 <a:solidFill>
                   <a:srgbClr val="141414"/>
                 </a:solidFill>
               </a:rPr>
               <a:t>FastAPI</a:t>
             </a:r>
-            <a:endParaRPr lang="en-US" sz="1300" dirty="0" smtClean="0"/>
+            <a:endParaRPr lang="en-US" sz="1300" dirty="0"/>
           </a:p>
           <a:p>
             <a:pPr marL="285750" indent="-285750" algn="l">
@@ -22733,30 +22068,14 @@
               <a:buChar char="•"/>
             </a:pPr>
             <a:r>
-              <a:rPr sz="1300" b="0" dirty="0" smtClean="0">
+              <a:rPr sz="1300" b="0" dirty="0">
                 <a:solidFill>
                   <a:srgbClr val="141414"/>
                 </a:solidFill>
               </a:rPr>
-              <a:t>REST </a:t>
+              <a:t>REST APIs and PostgreSQL</a:t>
             </a:r>
-            <a:r>
-              <a:rPr sz="1300" b="0" dirty="0">
-                <a:solidFill>
-                  <a:srgbClr val="141414"/>
-                </a:solidFill>
-              </a:rPr>
-              <a:t>APIs and </a:t>
-            </a:r>
-            <a:r>
-              <a:rPr sz="1300" b="0" dirty="0" smtClean="0">
-                <a:solidFill>
-                  <a:srgbClr val="141414"/>
-                </a:solidFill>
-              </a:rPr>
-              <a:t>PostgreSQL</a:t>
-            </a:r>
-            <a:endParaRPr lang="en-US" sz="1300" dirty="0" smtClean="0"/>
+            <a:endParaRPr lang="en-US" sz="1300" dirty="0"/>
           </a:p>
           <a:p>
             <a:pPr marL="285750" indent="-285750" algn="l">
@@ -22767,30 +22086,14 @@
               <a:buChar char="•"/>
             </a:pPr>
             <a:r>
-              <a:rPr sz="1300" b="0" dirty="0" smtClean="0">
+              <a:rPr sz="1300" b="0" dirty="0">
                 <a:solidFill>
                   <a:srgbClr val="141414"/>
                 </a:solidFill>
               </a:rPr>
-              <a:t>Authentication </a:t>
+              <a:t>Authentication and RBAC</a:t>
             </a:r>
-            <a:r>
-              <a:rPr sz="1300" b="0" dirty="0">
-                <a:solidFill>
-                  <a:srgbClr val="141414"/>
-                </a:solidFill>
-              </a:rPr>
-              <a:t>and </a:t>
-            </a:r>
-            <a:r>
-              <a:rPr sz="1300" b="0" dirty="0" smtClean="0">
-                <a:solidFill>
-                  <a:srgbClr val="141414"/>
-                </a:solidFill>
-              </a:rPr>
-              <a:t>RBAC</a:t>
-            </a:r>
-            <a:endParaRPr lang="en-US" sz="1300" dirty="0" smtClean="0"/>
+            <a:endParaRPr lang="en-US" sz="1300" dirty="0"/>
           </a:p>
           <a:p>
             <a:pPr marL="285750" indent="-285750" algn="l">
@@ -22801,30 +22104,14 @@
               <a:buChar char="•"/>
             </a:pPr>
             <a:r>
-              <a:rPr sz="1300" b="0" dirty="0" smtClean="0">
+              <a:rPr sz="1300" b="0" dirty="0">
                 <a:solidFill>
                   <a:srgbClr val="141414"/>
                 </a:solidFill>
               </a:rPr>
-              <a:t>FIR</a:t>
+              <a:t>FIR, investigation, evidence APIs</a:t>
             </a:r>
-            <a:r>
-              <a:rPr sz="1300" b="0" dirty="0">
-                <a:solidFill>
-                  <a:srgbClr val="141414"/>
-                </a:solidFill>
-              </a:rPr>
-              <a:t>, investigation, evidence </a:t>
-            </a:r>
-            <a:r>
-              <a:rPr sz="1300" b="0" dirty="0" smtClean="0">
-                <a:solidFill>
-                  <a:srgbClr val="141414"/>
-                </a:solidFill>
-              </a:rPr>
-              <a:t>APIs</a:t>
-            </a:r>
-            <a:endParaRPr lang="en-US" sz="1300" dirty="0" smtClean="0"/>
+            <a:endParaRPr lang="en-US" sz="1300" dirty="0"/>
           </a:p>
           <a:p>
             <a:pPr marL="285750" indent="-285750" algn="l">
@@ -22835,20 +22122,12 @@
               <a:buChar char="•"/>
             </a:pPr>
             <a:r>
-              <a:rPr sz="1300" b="0" dirty="0" smtClean="0">
+              <a:rPr sz="1300" b="0" dirty="0">
                 <a:solidFill>
                   <a:srgbClr val="141414"/>
                 </a:solidFill>
               </a:rPr>
-              <a:t>Backend </a:t>
-            </a:r>
-            <a:r>
-              <a:rPr sz="1300" b="0" dirty="0">
-                <a:solidFill>
-                  <a:srgbClr val="141414"/>
-                </a:solidFill>
-              </a:rPr>
-              <a:t>testing</a:t>
+              <a:t>Backend testing</a:t>
             </a:r>
           </a:p>
         </p:txBody>
@@ -23007,21 +22286,13 @@
                   <a:srgbClr val="141414"/>
                 </a:solidFill>
               </a:rPr>
-              <a:t>Frontend and Testing </a:t>
+              <a:t>Frontend and Testing Lead</a:t>
             </a:r>
-            <a:r>
-              <a:rPr sz="1300" b="1" dirty="0" smtClean="0">
-                <a:solidFill>
-                  <a:srgbClr val="141414"/>
-                </a:solidFill>
-              </a:rPr>
-              <a:t>Lead</a:t>
-            </a:r>
-            <a:endParaRPr lang="en-US" sz="1300" b="1" dirty="0" smtClean="0"/>
+            <a:endParaRPr lang="en-US" sz="1300" b="1" dirty="0"/>
           </a:p>
           <a:p>
             <a:pPr algn="l"/>
-            <a:endParaRPr lang="en-US" sz="1300" b="0" dirty="0" smtClean="0">
+            <a:endParaRPr lang="en-US" sz="1300" b="0" dirty="0">
               <a:solidFill>
                 <a:srgbClr val="141414"/>
               </a:solidFill>
@@ -23036,30 +22307,22 @@
               <a:buChar char="•"/>
             </a:pPr>
             <a:r>
-              <a:rPr sz="1300" b="0" dirty="0" smtClean="0">
+              <a:rPr sz="1300" b="0" dirty="0">
                 <a:solidFill>
                   <a:srgbClr val="141414"/>
                 </a:solidFill>
               </a:rPr>
-              <a:t>React </a:t>
+              <a:t>React and </a:t>
             </a:r>
             <a:r>
-              <a:rPr sz="1300" b="0" dirty="0">
-                <a:solidFill>
-                  <a:srgbClr val="141414"/>
-                </a:solidFill>
-              </a:rPr>
-              <a:t>and </a:t>
-            </a:r>
-            <a:r>
-              <a:rPr sz="1300" b="0" dirty="0" err="1" smtClean="0">
+              <a:rPr sz="1300" b="0" dirty="0" err="1">
                 <a:solidFill>
                   <a:srgbClr val="141414"/>
                 </a:solidFill>
               </a:rPr>
               <a:t>TypeScript</a:t>
             </a:r>
-            <a:endParaRPr lang="en-US" sz="1300" dirty="0" smtClean="0"/>
+            <a:endParaRPr lang="en-US" sz="1300" dirty="0"/>
           </a:p>
           <a:p>
             <a:pPr marL="285750" indent="-285750" algn="l">
@@ -23070,30 +22333,14 @@
               <a:buChar char="•"/>
             </a:pPr>
             <a:r>
-              <a:rPr sz="1300" b="0" dirty="0" smtClean="0">
+              <a:rPr sz="1300" b="0" dirty="0">
                 <a:solidFill>
                   <a:srgbClr val="141414"/>
                 </a:solidFill>
               </a:rPr>
-              <a:t>UI </a:t>
+              <a:t>UI and UX</a:t>
             </a:r>
-            <a:r>
-              <a:rPr sz="1300" b="0" dirty="0">
-                <a:solidFill>
-                  <a:srgbClr val="141414"/>
-                </a:solidFill>
-              </a:rPr>
-              <a:t>and </a:t>
-            </a:r>
-            <a:r>
-              <a:rPr sz="1300" b="0" dirty="0" smtClean="0">
-                <a:solidFill>
-                  <a:srgbClr val="141414"/>
-                </a:solidFill>
-              </a:rPr>
-              <a:t>UX</a:t>
-            </a:r>
-            <a:endParaRPr lang="en-US" sz="1300" dirty="0" smtClean="0"/>
+            <a:endParaRPr lang="en-US" sz="1300" dirty="0"/>
           </a:p>
           <a:p>
             <a:pPr marL="285750" indent="-285750" algn="l">
@@ -23104,30 +22351,14 @@
               <a:buChar char="•"/>
             </a:pPr>
             <a:r>
-              <a:rPr sz="1300" b="0" dirty="0" smtClean="0">
+              <a:rPr sz="1300" b="0" dirty="0">
                 <a:solidFill>
                   <a:srgbClr val="141414"/>
                 </a:solidFill>
               </a:rPr>
-              <a:t>Dashboards </a:t>
+              <a:t>Dashboards and forms</a:t>
             </a:r>
-            <a:r>
-              <a:rPr sz="1300" b="0" dirty="0">
-                <a:solidFill>
-                  <a:srgbClr val="141414"/>
-                </a:solidFill>
-              </a:rPr>
-              <a:t>and </a:t>
-            </a:r>
-            <a:r>
-              <a:rPr sz="1300" b="0" dirty="0" smtClean="0">
-                <a:solidFill>
-                  <a:srgbClr val="141414"/>
-                </a:solidFill>
-              </a:rPr>
-              <a:t>forms</a:t>
-            </a:r>
-            <a:endParaRPr lang="en-US" sz="1300" dirty="0" smtClean="0"/>
+            <a:endParaRPr lang="en-US" sz="1300" dirty="0"/>
           </a:p>
           <a:p>
             <a:pPr marL="285750" indent="-285750" algn="l">
@@ -23138,30 +22369,14 @@
               <a:buChar char="•"/>
             </a:pPr>
             <a:r>
-              <a:rPr sz="1300" b="0" dirty="0" smtClean="0">
+              <a:rPr sz="1300" b="0" dirty="0">
                 <a:solidFill>
                   <a:srgbClr val="141414"/>
                 </a:solidFill>
               </a:rPr>
-              <a:t>Audit </a:t>
+              <a:t>Audit and charts interface</a:t>
             </a:r>
-            <a:r>
-              <a:rPr sz="1300" b="0" dirty="0">
-                <a:solidFill>
-                  <a:srgbClr val="141414"/>
-                </a:solidFill>
-              </a:rPr>
-              <a:t>and charts </a:t>
-            </a:r>
-            <a:r>
-              <a:rPr sz="1300" b="0" dirty="0" smtClean="0">
-                <a:solidFill>
-                  <a:srgbClr val="141414"/>
-                </a:solidFill>
-              </a:rPr>
-              <a:t>interface</a:t>
-            </a:r>
-            <a:endParaRPr lang="en-US" sz="1300" dirty="0" smtClean="0"/>
+            <a:endParaRPr lang="en-US" sz="1300" dirty="0"/>
           </a:p>
           <a:p>
             <a:pPr marL="285750" indent="-285750" algn="l">
@@ -23172,20 +22387,12 @@
               <a:buChar char="•"/>
             </a:pPr>
             <a:r>
-              <a:rPr sz="1300" b="0" dirty="0" smtClean="0">
+              <a:rPr sz="1300" b="0" dirty="0">
                 <a:solidFill>
                   <a:srgbClr val="141414"/>
                 </a:solidFill>
               </a:rPr>
-              <a:t>UI </a:t>
-            </a:r>
-            <a:r>
-              <a:rPr sz="1300" b="0" dirty="0">
-                <a:solidFill>
-                  <a:srgbClr val="141414"/>
-                </a:solidFill>
-              </a:rPr>
-              <a:t>and usability testing</a:t>
+              <a:t>UI and usability testing</a:t>
             </a:r>
           </a:p>
         </p:txBody>
@@ -23220,19 +22427,10 @@
                 </a:solidFill>
                 <a:latin typeface="Arial"/>
               </a:rPr>
-              <a:t>Shared: research, documentation, GitHub, code review, integration, security testing, final report, </a:t>
+              <a:t>Shared: research, documentation, GitHub, code review, integration, security testing, final report, presentation</a:t>
             </a:r>
             <a:r>
-              <a:rPr sz="1400" b="1" dirty="0" smtClean="0">
-                <a:solidFill>
-                  <a:srgbClr val="1F497D"/>
-                </a:solidFill>
-                <a:latin typeface="Arial"/>
-              </a:rPr>
-              <a:t>presentation</a:t>
-            </a:r>
-            <a:r>
-              <a:rPr lang="en-US" sz="1400" b="1" dirty="0" smtClean="0">
+              <a:rPr lang="en-US" sz="1400" b="1" dirty="0">
                 <a:solidFill>
                   <a:srgbClr val="1F497D"/>
                 </a:solidFill>
@@ -23241,22 +22439,13 @@
               <a:t> and</a:t>
             </a:r>
             <a:r>
-              <a:rPr sz="1400" b="1" dirty="0" smtClean="0">
+              <a:rPr sz="1400" b="1" dirty="0">
                 <a:solidFill>
                   <a:srgbClr val="1F497D"/>
                 </a:solidFill>
                 <a:latin typeface="Arial"/>
               </a:rPr>
-              <a:t> </a:t>
-            </a:r>
-            <a:r>
-              <a:rPr sz="1400" b="1" dirty="0">
-                <a:solidFill>
-                  <a:srgbClr val="1F497D"/>
-                </a:solidFill>
-                <a:latin typeface="Arial"/>
-              </a:rPr>
-              <a:t>viva preparation.</a:t>
+              <a:t> viva preparation.</a:t>
             </a:r>
           </a:p>
         </p:txBody>
@@ -23278,13 +22467,6 @@
       </p:transition>
     </mc:Fallback>
   </mc:AlternateContent>
-  <p:timing>
-    <p:tnLst>
-      <p:par>
-        <p:cTn id="1" dur="indefinite" restart="never" nodeType="tmRoot"/>
-      </p:par>
-    </p:tnLst>
-  </p:timing>
 </p:sld>
 </file>
 
@@ -23468,13 +22650,6 @@
       </p:transition>
     </mc:Fallback>
   </mc:AlternateContent>
-  <p:timing>
-    <p:tnLst>
-      <p:par>
-        <p:cTn id="1" dur="indefinite" restart="never" nodeType="tmRoot"/>
-      </p:par>
-    </p:tnLst>
-  </p:timing>
 </p:sld>
 </file>
 
@@ -23530,13 +22705,6 @@
   <p:transition spd="slow">
     <p:cover/>
   </p:transition>
-  <p:timing>
-    <p:tnLst>
-      <p:par>
-        <p:cTn id="1" dur="indefinite" restart="never" nodeType="tmRoot"/>
-      </p:par>
-    </p:tnLst>
-  </p:timing>
 </p:sld>
 </file>
 
@@ -23623,16 +22791,10 @@
               </a:defRPr>
             </a:pPr>
             <a:r>
-              <a:rPr dirty="0" smtClean="0">
+              <a:rPr dirty="0">
                 <a:latin typeface="Arial"/>
               </a:rPr>
-              <a:t>Academic </a:t>
-            </a:r>
-            <a:r>
-              <a:rPr dirty="0">
-                <a:latin typeface="Arial"/>
-              </a:rPr>
-              <a:t>prototype only, not a production police system</a:t>
+              <a:t>Academic prototype only, not a production police system</a:t>
             </a:r>
           </a:p>
           <a:p>
@@ -23653,16 +22815,10 @@
               </a:defRPr>
             </a:pPr>
             <a:r>
-              <a:rPr dirty="0" smtClean="0">
+              <a:rPr dirty="0">
                 <a:latin typeface="Arial"/>
               </a:rPr>
-              <a:t>Synthetic </a:t>
-            </a:r>
-            <a:r>
-              <a:rPr dirty="0">
-                <a:latin typeface="Arial"/>
-              </a:rPr>
-              <a:t>or demonstration data only</a:t>
+              <a:t>Synthetic or demonstration data only</a:t>
             </a:r>
           </a:p>
           <a:p>
@@ -23683,16 +22839,10 @@
               </a:defRPr>
             </a:pPr>
             <a:r>
-              <a:rPr dirty="0" smtClean="0">
+              <a:rPr dirty="0">
                 <a:latin typeface="Arial"/>
               </a:rPr>
-              <a:t>No </a:t>
-            </a:r>
-            <a:r>
-              <a:rPr dirty="0">
-                <a:latin typeface="Arial"/>
-              </a:rPr>
-              <a:t>NADRA, live police, or government system integration</a:t>
+              <a:t>No NADRA, live police, or government system integration</a:t>
             </a:r>
           </a:p>
           <a:p>
@@ -23713,16 +22863,10 @@
               </a:defRPr>
             </a:pPr>
             <a:r>
-              <a:rPr dirty="0" smtClean="0">
+              <a:rPr dirty="0">
                 <a:latin typeface="Arial"/>
               </a:rPr>
-              <a:t>Small </a:t>
-            </a:r>
-            <a:r>
-              <a:rPr dirty="0">
-                <a:latin typeface="Arial"/>
-              </a:rPr>
-              <a:t>controlled blockchain network for demonstration</a:t>
+              <a:t>Small controlled blockchain network for demonstration</a:t>
             </a:r>
           </a:p>
           <a:p>
@@ -23743,16 +22887,10 @@
               </a:defRPr>
             </a:pPr>
             <a:r>
-              <a:rPr dirty="0" smtClean="0">
+              <a:rPr dirty="0">
                 <a:latin typeface="Arial"/>
               </a:rPr>
-              <a:t>Performance </a:t>
-            </a:r>
-            <a:r>
-              <a:rPr dirty="0">
-                <a:latin typeface="Arial"/>
-              </a:rPr>
-              <a:t>and scale testing limited by available student infrastructure</a:t>
+              <a:t>Performance and scale testing limited by available student infrastructure</a:t>
             </a:r>
           </a:p>
           <a:p>
@@ -23773,16 +22911,10 @@
               </a:defRPr>
             </a:pPr>
             <a:r>
-              <a:rPr dirty="0" smtClean="0">
+              <a:rPr dirty="0">
                 <a:latin typeface="Arial"/>
               </a:rPr>
-              <a:t>No </a:t>
-            </a:r>
-            <a:r>
-              <a:rPr dirty="0">
-                <a:latin typeface="Arial"/>
-              </a:rPr>
-              <a:t>legally binding digital FIR functionality</a:t>
+              <a:t>No legally binding digital FIR functionality</a:t>
             </a:r>
           </a:p>
         </p:txBody>
@@ -23964,13 +23096,6 @@
       </p:transition>
     </mc:Fallback>
   </mc:AlternateContent>
-  <p:timing>
-    <p:tnLst>
-      <p:par>
-        <p:cTn id="1" dur="indefinite" restart="never" nodeType="tmRoot"/>
-      </p:par>
-    </p:tnLst>
-  </p:timing>
 </p:sld>
 </file>
 
@@ -24173,30 +23298,14 @@
               <a:buChar char="•"/>
             </a:pPr>
             <a:r>
-              <a:rPr sz="1500" b="0" dirty="0" smtClean="0">
+              <a:rPr sz="1500" b="0" dirty="0">
                 <a:solidFill>
                   <a:srgbClr val="141414"/>
                 </a:solidFill>
               </a:rPr>
-              <a:t>Improved </a:t>
+              <a:t>Improved record integrity through cryptographic verification</a:t>
             </a:r>
-            <a:r>
-              <a:rPr sz="1500" b="0" dirty="0">
-                <a:solidFill>
-                  <a:srgbClr val="141414"/>
-                </a:solidFill>
-              </a:rPr>
-              <a:t>record integrity through cryptographic </a:t>
-            </a:r>
-            <a:r>
-              <a:rPr sz="1500" b="0" dirty="0" smtClean="0">
-                <a:solidFill>
-                  <a:srgbClr val="141414"/>
-                </a:solidFill>
-              </a:rPr>
-              <a:t>verification</a:t>
-            </a:r>
-            <a:endParaRPr lang="en-US" sz="1500" dirty="0" smtClean="0"/>
+            <a:endParaRPr lang="en-US" sz="1500" dirty="0"/>
           </a:p>
           <a:p>
             <a:pPr marL="285750" indent="-285750" algn="l">
@@ -24207,30 +23316,14 @@
               <a:buChar char="•"/>
             </a:pPr>
             <a:r>
-              <a:rPr sz="1500" b="0" dirty="0" smtClean="0">
+              <a:rPr sz="1500" b="0" dirty="0">
                 <a:solidFill>
                   <a:srgbClr val="141414"/>
                 </a:solidFill>
               </a:rPr>
-              <a:t>Stronger </a:t>
+              <a:t>Stronger accountability through RBAC and blockchain audit trails</a:t>
             </a:r>
-            <a:r>
-              <a:rPr sz="1500" b="0" dirty="0">
-                <a:solidFill>
-                  <a:srgbClr val="141414"/>
-                </a:solidFill>
-              </a:rPr>
-              <a:t>accountability through RBAC and blockchain audit </a:t>
-            </a:r>
-            <a:r>
-              <a:rPr sz="1500" b="0" dirty="0" smtClean="0">
-                <a:solidFill>
-                  <a:srgbClr val="141414"/>
-                </a:solidFill>
-              </a:rPr>
-              <a:t>trails</a:t>
-            </a:r>
-            <a:endParaRPr lang="en-US" sz="1500" dirty="0" smtClean="0"/>
+            <a:endParaRPr lang="en-US" sz="1500" dirty="0"/>
           </a:p>
           <a:p>
             <a:pPr marL="285750" indent="-285750" algn="l">
@@ -24241,30 +23334,14 @@
               <a:buChar char="•"/>
             </a:pPr>
             <a:r>
-              <a:rPr sz="1500" b="0" dirty="0" smtClean="0">
+              <a:rPr sz="1500" b="0" dirty="0">
                 <a:solidFill>
                   <a:srgbClr val="141414"/>
                 </a:solidFill>
               </a:rPr>
-              <a:t>Clearer </a:t>
+              <a:t>Clearer visibility into the FIR lifecycle</a:t>
             </a:r>
-            <a:r>
-              <a:rPr sz="1500" b="0" dirty="0">
-                <a:solidFill>
-                  <a:srgbClr val="141414"/>
-                </a:solidFill>
-              </a:rPr>
-              <a:t>visibility into the FIR </a:t>
-            </a:r>
-            <a:r>
-              <a:rPr sz="1500" b="0" dirty="0" smtClean="0">
-                <a:solidFill>
-                  <a:srgbClr val="141414"/>
-                </a:solidFill>
-              </a:rPr>
-              <a:t>lifecycle</a:t>
-            </a:r>
-            <a:endParaRPr lang="en-US" sz="1500" dirty="0" smtClean="0"/>
+            <a:endParaRPr lang="en-US" sz="1500" dirty="0"/>
           </a:p>
           <a:p>
             <a:pPr marL="285750" indent="-285750" algn="l">
@@ -24275,30 +23352,14 @@
               <a:buChar char="•"/>
             </a:pPr>
             <a:r>
-              <a:rPr sz="1500" b="0" dirty="0" smtClean="0">
+              <a:rPr sz="1500" b="0" dirty="0">
                 <a:solidFill>
                   <a:srgbClr val="141414"/>
                 </a:solidFill>
               </a:rPr>
-              <a:t>Tamper </a:t>
+              <a:t>Tamper evident evidence and document history</a:t>
             </a:r>
-            <a:r>
-              <a:rPr sz="1500" b="0" dirty="0">
-                <a:solidFill>
-                  <a:srgbClr val="141414"/>
-                </a:solidFill>
-              </a:rPr>
-              <a:t>evident evidence and document </a:t>
-            </a:r>
-            <a:r>
-              <a:rPr sz="1500" b="0" dirty="0" smtClean="0">
-                <a:solidFill>
-                  <a:srgbClr val="141414"/>
-                </a:solidFill>
-              </a:rPr>
-              <a:t>history</a:t>
-            </a:r>
-            <a:endParaRPr lang="en-US" sz="1500" dirty="0" smtClean="0"/>
+            <a:endParaRPr lang="en-US" sz="1500" dirty="0"/>
           </a:p>
           <a:p>
             <a:pPr marL="285750" indent="-285750" algn="l">
@@ -24309,20 +23370,12 @@
               <a:buChar char="•"/>
             </a:pPr>
             <a:r>
-              <a:rPr sz="1500" b="0" dirty="0" smtClean="0">
+              <a:rPr sz="1500" b="0" dirty="0">
                 <a:solidFill>
                   <a:srgbClr val="141414"/>
                 </a:solidFill>
               </a:rPr>
-              <a:t>Practical </a:t>
-            </a:r>
-            <a:r>
-              <a:rPr sz="1500" b="0" dirty="0">
-                <a:solidFill>
-                  <a:srgbClr val="141414"/>
-                </a:solidFill>
-              </a:rPr>
-              <a:t>demonstration of permissioned blockchain in a public sector workflow</a:t>
+              <a:t>Practical demonstration of permissioned blockchain in a public sector workflow</a:t>
             </a:r>
           </a:p>
         </p:txBody>
@@ -24479,30 +23532,14 @@
               <a:buChar char="•"/>
             </a:pPr>
             <a:r>
-              <a:rPr sz="1500" b="0" dirty="0" smtClean="0">
+              <a:rPr sz="1500" b="0" dirty="0">
                 <a:solidFill>
                   <a:srgbClr val="141414"/>
                 </a:solidFill>
               </a:rPr>
-              <a:t>Authorized </a:t>
+              <a:t>Authorized users authenticate and roles are enforced</a:t>
             </a:r>
-            <a:r>
-              <a:rPr sz="1500" b="0" dirty="0">
-                <a:solidFill>
-                  <a:srgbClr val="141414"/>
-                </a:solidFill>
-              </a:rPr>
-              <a:t>users authenticate and roles are </a:t>
-            </a:r>
-            <a:r>
-              <a:rPr sz="1500" b="0" dirty="0" smtClean="0">
-                <a:solidFill>
-                  <a:srgbClr val="141414"/>
-                </a:solidFill>
-              </a:rPr>
-              <a:t>enforced</a:t>
-            </a:r>
-            <a:endParaRPr lang="en-US" sz="1500" dirty="0" smtClean="0"/>
+            <a:endParaRPr lang="en-US" sz="1500" dirty="0"/>
           </a:p>
           <a:p>
             <a:pPr marL="285750" indent="-285750" algn="l">
@@ -24510,30 +23547,14 @@
               <a:buChar char="•"/>
             </a:pPr>
             <a:r>
-              <a:rPr sz="1500" b="0" dirty="0" smtClean="0">
+              <a:rPr sz="1500" b="0" dirty="0">
                 <a:solidFill>
                   <a:srgbClr val="141414"/>
                 </a:solidFill>
               </a:rPr>
-              <a:t>FIRs </a:t>
+              <a:t>FIRs move through defined workflow states</a:t>
             </a:r>
-            <a:r>
-              <a:rPr sz="1500" b="0" dirty="0">
-                <a:solidFill>
-                  <a:srgbClr val="141414"/>
-                </a:solidFill>
-              </a:rPr>
-              <a:t>move through defined workflow </a:t>
-            </a:r>
-            <a:r>
-              <a:rPr sz="1500" b="0" dirty="0" smtClean="0">
-                <a:solidFill>
-                  <a:srgbClr val="141414"/>
-                </a:solidFill>
-              </a:rPr>
-              <a:t>states</a:t>
-            </a:r>
-            <a:endParaRPr lang="en-US" sz="1500" dirty="0" smtClean="0"/>
+            <a:endParaRPr lang="en-US" sz="1500" dirty="0"/>
           </a:p>
           <a:p>
             <a:pPr marL="285750" indent="-285750" algn="l">
@@ -24541,30 +23562,14 @@
               <a:buChar char="•"/>
             </a:pPr>
             <a:r>
-              <a:rPr sz="1500" b="0" dirty="0" smtClean="0">
+              <a:rPr sz="1500" b="0" dirty="0">
                 <a:solidFill>
                   <a:srgbClr val="141414"/>
                 </a:solidFill>
               </a:rPr>
-              <a:t>Evidence </a:t>
+              <a:t>Evidence hashes are generated and verified</a:t>
             </a:r>
-            <a:r>
-              <a:rPr sz="1500" b="0" dirty="0">
-                <a:solidFill>
-                  <a:srgbClr val="141414"/>
-                </a:solidFill>
-              </a:rPr>
-              <a:t>hashes are generated and </a:t>
-            </a:r>
-            <a:r>
-              <a:rPr sz="1500" b="0" dirty="0" smtClean="0">
-                <a:solidFill>
-                  <a:srgbClr val="141414"/>
-                </a:solidFill>
-              </a:rPr>
-              <a:t>verified</a:t>
-            </a:r>
-            <a:endParaRPr lang="en-US" sz="1500" dirty="0" smtClean="0"/>
+            <a:endParaRPr lang="en-US" sz="1500" dirty="0"/>
           </a:p>
           <a:p>
             <a:pPr marL="285750" indent="-285750" algn="l">
@@ -24572,30 +23577,14 @@
               <a:buChar char="•"/>
             </a:pPr>
             <a:r>
-              <a:rPr sz="1500" b="0" dirty="0" smtClean="0">
+              <a:rPr sz="1500" b="0" dirty="0">
                 <a:solidFill>
                   <a:srgbClr val="141414"/>
                 </a:solidFill>
               </a:rPr>
-              <a:t>Key </a:t>
+              <a:t>Key operations produce blockchain transactions</a:t>
             </a:r>
-            <a:r>
-              <a:rPr sz="1500" b="0" dirty="0">
-                <a:solidFill>
-                  <a:srgbClr val="141414"/>
-                </a:solidFill>
-              </a:rPr>
-              <a:t>operations produce blockchain </a:t>
-            </a:r>
-            <a:r>
-              <a:rPr sz="1500" b="0" dirty="0" smtClean="0">
-                <a:solidFill>
-                  <a:srgbClr val="141414"/>
-                </a:solidFill>
-              </a:rPr>
-              <a:t>transactions</a:t>
-            </a:r>
-            <a:endParaRPr lang="en-US" sz="1500" dirty="0" smtClean="0"/>
+            <a:endParaRPr lang="en-US" sz="1500" dirty="0"/>
           </a:p>
           <a:p>
             <a:pPr marL="285750" indent="-285750" algn="l">
@@ -24603,30 +23592,14 @@
               <a:buChar char="•"/>
             </a:pPr>
             <a:r>
-              <a:rPr sz="1500" b="0" dirty="0" smtClean="0">
+              <a:rPr sz="1500" b="0" dirty="0">
                 <a:solidFill>
                   <a:srgbClr val="141414"/>
                 </a:solidFill>
               </a:rPr>
-              <a:t>History </a:t>
+              <a:t>History can be retrieved and reconstructed</a:t>
             </a:r>
-            <a:r>
-              <a:rPr sz="1500" b="0" dirty="0">
-                <a:solidFill>
-                  <a:srgbClr val="141414"/>
-                </a:solidFill>
-              </a:rPr>
-              <a:t>can be retrieved and </a:t>
-            </a:r>
-            <a:r>
-              <a:rPr sz="1500" b="0" dirty="0" smtClean="0">
-                <a:solidFill>
-                  <a:srgbClr val="141414"/>
-                </a:solidFill>
-              </a:rPr>
-              <a:t>reconstructed</a:t>
-            </a:r>
-            <a:endParaRPr lang="en-US" sz="1500" dirty="0" smtClean="0"/>
+            <a:endParaRPr lang="en-US" sz="1500" dirty="0"/>
           </a:p>
           <a:p>
             <a:pPr marL="285750" indent="-285750" algn="l">
@@ -24634,30 +23607,14 @@
               <a:buChar char="•"/>
             </a:pPr>
             <a:r>
-              <a:rPr sz="1500" b="0" dirty="0" smtClean="0">
+              <a:rPr sz="1500" b="0" dirty="0">
                 <a:solidFill>
                   <a:srgbClr val="141414"/>
                 </a:solidFill>
               </a:rPr>
-              <a:t>Unauthorized </a:t>
+              <a:t>Unauthorized actions are rejected</a:t>
             </a:r>
-            <a:r>
-              <a:rPr sz="1500" b="0" dirty="0">
-                <a:solidFill>
-                  <a:srgbClr val="141414"/>
-                </a:solidFill>
-              </a:rPr>
-              <a:t>actions are </a:t>
-            </a:r>
-            <a:r>
-              <a:rPr sz="1500" b="0" dirty="0" smtClean="0">
-                <a:solidFill>
-                  <a:srgbClr val="141414"/>
-                </a:solidFill>
-              </a:rPr>
-              <a:t>rejected</a:t>
-            </a:r>
-            <a:endParaRPr lang="en-US" sz="1500" dirty="0" smtClean="0"/>
+            <a:endParaRPr lang="en-US" sz="1500" dirty="0"/>
           </a:p>
           <a:p>
             <a:pPr marL="285750" indent="-285750" algn="l">
@@ -24665,20 +23622,12 @@
               <a:buChar char="•"/>
             </a:pPr>
             <a:r>
-              <a:rPr sz="1500" b="0" dirty="0" smtClean="0">
+              <a:rPr sz="1500" b="0" dirty="0">
                 <a:solidFill>
                   <a:srgbClr val="141414"/>
                 </a:solidFill>
               </a:rPr>
-              <a:t>End </a:t>
-            </a:r>
-            <a:r>
-              <a:rPr sz="1500" b="0" dirty="0">
-                <a:solidFill>
-                  <a:srgbClr val="141414"/>
-                </a:solidFill>
-              </a:rPr>
-              <a:t>to end prototype works with synthetic data</a:t>
+              <a:t>End to end prototype works with synthetic data</a:t>
             </a:r>
           </a:p>
         </p:txBody>
@@ -24700,13 +23649,6 @@
       </p:transition>
     </mc:Fallback>
   </mc:AlternateContent>
-  <p:timing>
-    <p:tnLst>
-      <p:par>
-        <p:cTn id="1" dur="indefinite" restart="never" nodeType="tmRoot"/>
-      </p:par>
-    </p:tnLst>
-  </p:timing>
 </p:sld>
 </file>
 
@@ -24771,13 +23713,6 @@
       </p:transition>
     </mc:Fallback>
   </mc:AlternateContent>
-  <p:timing>
-    <p:tnLst>
-      <p:par>
-        <p:cTn id="1" dur="indefinite" restart="never" nodeType="tmRoot"/>
-      </p:par>
-    </p:tnLst>
-  </p:timing>
 </p:sld>
 </file>
 
@@ -24826,25 +23761,16 @@
               </a:lnSpc>
             </a:pPr>
             <a:r>
-              <a:rPr sz="2400" b="1" dirty="0" smtClean="0">
+              <a:rPr sz="2400" b="1" dirty="0">
                 <a:solidFill>
                   <a:srgbClr val="1F497D"/>
                 </a:solidFill>
                 <a:latin typeface="Arial"/>
               </a:rPr>
-              <a:t>Digital </a:t>
+              <a:t>Digital FIR combines a conventional secure database with a permissioned </a:t>
             </a:r>
             <a:r>
-              <a:rPr sz="2400" b="1" dirty="0" smtClean="0">
-                <a:solidFill>
-                  <a:srgbClr val="1F497D"/>
-                </a:solidFill>
-                <a:latin typeface="Arial"/>
-              </a:rPr>
-              <a:t>FIR combines a conventional secure database with a permissioned </a:t>
-            </a:r>
-            <a:r>
-              <a:rPr sz="2400" b="1" dirty="0" err="1" smtClean="0">
+              <a:rPr sz="2400" b="1" dirty="0" err="1">
                 <a:solidFill>
                   <a:srgbClr val="1F497D"/>
                 </a:solidFill>
@@ -24853,7 +23779,7 @@
               <a:t>Hyperledger</a:t>
             </a:r>
             <a:r>
-              <a:rPr sz="2400" b="1" dirty="0" smtClean="0">
+              <a:rPr sz="2400" b="1" dirty="0">
                 <a:solidFill>
                   <a:srgbClr val="1F497D"/>
                 </a:solidFill>
@@ -24861,12 +23787,6 @@
               </a:rPr>
               <a:t> Fabric layer to improve integrity, traceability and auditability of FIR workflows.</a:t>
             </a:r>
-            <a:endParaRPr sz="2400" b="1" dirty="0">
-              <a:solidFill>
-                <a:srgbClr val="1F497D"/>
-              </a:solidFill>
-              <a:latin typeface="Arial"/>
-            </a:endParaRPr>
           </a:p>
         </p:txBody>
       </p:sp>
@@ -25025,19 +23945,10 @@
                 </a:solidFill>
                 <a:latin typeface="Arial"/>
               </a:rPr>
-              <a:t>Sensitive information stays off chain. Hashes, transactions, workflow </a:t>
+              <a:t>Sensitive information stays off chain. Hashes, transactions, workflow events</a:t>
             </a:r>
             <a:r>
-              <a:rPr sz="1600" b="0" dirty="0" smtClean="0">
-                <a:solidFill>
-                  <a:srgbClr val="141414"/>
-                </a:solidFill>
-                <a:latin typeface="Arial"/>
-              </a:rPr>
-              <a:t>events</a:t>
-            </a:r>
-            <a:r>
-              <a:rPr lang="en-US" sz="1600" b="0" dirty="0" smtClean="0">
+              <a:rPr lang="en-US" sz="1600" b="0" dirty="0">
                 <a:solidFill>
                   <a:srgbClr val="141414"/>
                 </a:solidFill>
@@ -25046,22 +23957,13 @@
               <a:t> and</a:t>
             </a:r>
             <a:r>
-              <a:rPr sz="1600" b="0" dirty="0" smtClean="0">
+              <a:rPr sz="1600" b="0" dirty="0">
                 <a:solidFill>
                   <a:srgbClr val="141414"/>
                 </a:solidFill>
                 <a:latin typeface="Arial"/>
               </a:rPr>
-              <a:t> </a:t>
-            </a:r>
-            <a:r>
-              <a:rPr sz="1600" b="0" dirty="0">
-                <a:solidFill>
-                  <a:srgbClr val="141414"/>
-                </a:solidFill>
-                <a:latin typeface="Arial"/>
-              </a:rPr>
-              <a:t>integrity metadata provide the verifiable audit layer.</a:t>
+              <a:t> integrity metadata provide the verifiable audit layer.</a:t>
             </a:r>
           </a:p>
         </p:txBody>
@@ -25098,9 +24000,6 @@
               </a:rPr>
               <a:t>Thank You</a:t>
             </a:r>
-            <a:r>
-              <a:t/>
-            </a:r>
             <a:br/>
             <a:r>
               <a:rPr sz="2400" b="1">
@@ -25131,13 +24030,6 @@
       </p:transition>
     </mc:Fallback>
   </mc:AlternateContent>
-  <p:timing>
-    <p:tnLst>
-      <p:par>
-        <p:cTn id="1" dur="indefinite" restart="never" nodeType="tmRoot"/>
-      </p:par>
-    </p:tnLst>
-  </p:timing>
 </p:sld>
 </file>
 
@@ -25208,7 +24100,7 @@
         <p:spPr>
           <a:xfrm>
             <a:off x="640080" y="1508760"/>
-            <a:ext cx="3749039" cy="4210383"/>
+            <a:ext cx="3695097" cy="4656659"/>
           </a:xfrm>
           <a:prstGeom prst="rect">
             <a:avLst/>
@@ -25235,17 +24127,14 @@
               </a:defRPr>
             </a:pPr>
             <a:r>
-              <a:rPr sz="2400" dirty="0" smtClean="0">
+              <a:rPr sz="2400" dirty="0">
                 <a:latin typeface="Arial"/>
               </a:rPr>
-              <a:t>Introduction </a:t>
+              <a:t>Introduction and Background</a:t>
             </a:r>
-            <a:r>
-              <a:rPr sz="2400" dirty="0">
-                <a:latin typeface="Arial"/>
-              </a:rPr>
-              <a:t>and Background</a:t>
-            </a:r>
+            <a:endParaRPr lang="en-US" sz="2400" dirty="0">
+              <a:latin typeface="Arial"/>
+            </a:endParaRPr>
           </a:p>
           <a:p>
             <a:pPr marL="342900" indent="-342900">
@@ -25262,10 +24151,10 @@
               </a:defRPr>
             </a:pPr>
             <a:r>
-              <a:rPr lang="en-US" sz="2400" dirty="0" smtClean="0">
+              <a:rPr sz="2400" dirty="0">
                 <a:latin typeface="Arial"/>
               </a:rPr>
-              <a:t>Literature Review</a:t>
+              <a:t>Existing Systems in Pakistan</a:t>
             </a:r>
           </a:p>
           <a:p>
@@ -25283,16 +24172,10 @@
               </a:defRPr>
             </a:pPr>
             <a:r>
-              <a:rPr sz="2400" dirty="0" smtClean="0">
+              <a:rPr sz="2400" dirty="0">
                 <a:latin typeface="Arial"/>
               </a:rPr>
-              <a:t>Existing </a:t>
-            </a:r>
-            <a:r>
-              <a:rPr sz="2400" dirty="0">
-                <a:latin typeface="Arial"/>
-              </a:rPr>
-              <a:t>Systems in Pakistan</a:t>
+              <a:t>Gap Analysis</a:t>
             </a:r>
           </a:p>
           <a:p>
@@ -25310,16 +24193,10 @@
               </a:defRPr>
             </a:pPr>
             <a:r>
-              <a:rPr sz="2400" dirty="0" smtClean="0">
+              <a:rPr sz="2400" dirty="0">
                 <a:latin typeface="Arial"/>
               </a:rPr>
-              <a:t>Gap </a:t>
-            </a:r>
-            <a:r>
-              <a:rPr sz="2400" dirty="0">
-                <a:latin typeface="Arial"/>
-              </a:rPr>
-              <a:t>Analysis</a:t>
+              <a:t>Problem Statement</a:t>
             </a:r>
           </a:p>
           <a:p>
@@ -25337,16 +24214,10 @@
               </a:defRPr>
             </a:pPr>
             <a:r>
-              <a:rPr sz="2400" dirty="0" smtClean="0">
+              <a:rPr sz="2400" dirty="0">
                 <a:latin typeface="Arial"/>
               </a:rPr>
-              <a:t>Problem </a:t>
-            </a:r>
-            <a:r>
-              <a:rPr sz="2400" dirty="0">
-                <a:latin typeface="Arial"/>
-              </a:rPr>
-              <a:t>Statement</a:t>
+              <a:t>Proposed Solution and Methodology</a:t>
             </a:r>
           </a:p>
           <a:p>
@@ -25364,17 +24235,14 @@
               </a:defRPr>
             </a:pPr>
             <a:r>
-              <a:rPr sz="2400" dirty="0" smtClean="0">
+              <a:rPr sz="2400" dirty="0">
                 <a:latin typeface="Arial"/>
               </a:rPr>
-              <a:t>Proposed </a:t>
+              <a:t>System Architecture</a:t>
             </a:r>
-            <a:r>
-              <a:rPr sz="2400" dirty="0">
-                <a:latin typeface="Arial"/>
-              </a:rPr>
-              <a:t>Solution and Methodology</a:t>
-            </a:r>
+            <a:endParaRPr lang="en-GB" sz="2400" dirty="0">
+              <a:latin typeface="Arial"/>
+            </a:endParaRPr>
           </a:p>
           <a:p>
             <a:pPr marL="342900" indent="-342900">
@@ -25391,17 +24259,27 @@
               </a:defRPr>
             </a:pPr>
             <a:r>
-              <a:rPr sz="2400" dirty="0" smtClean="0">
-                <a:latin typeface="Arial"/>
-              </a:rPr>
-              <a:t>System </a:t>
+              <a:rPr lang="en-GB" sz="2400" dirty="0"/>
+              <a:t>Project Scope</a:t>
             </a:r>
-            <a:r>
-              <a:rPr sz="2400" dirty="0">
-                <a:latin typeface="Arial"/>
-              </a:rPr>
-              <a:t>Architecture</a:t>
-            </a:r>
+          </a:p>
+          <a:p>
+            <a:pPr marL="342900" indent="-342900">
+              <a:spcAft>
+                <a:spcPts val="600"/>
+              </a:spcAft>
+              <a:buFont typeface="Arial" panose="020B0604020202020204" pitchFamily="34" charset="0"/>
+              <a:buChar char="•"/>
+              <a:defRPr sz="1600">
+                <a:solidFill>
+                  <a:srgbClr val="141414"/>
+                </a:solidFill>
+                <a:latin typeface="Arial"/>
+              </a:defRPr>
+            </a:pPr>
+            <a:endParaRPr sz="2400" dirty="0">
+              <a:latin typeface="Arial"/>
+            </a:endParaRPr>
           </a:p>
         </p:txBody>
       </p:sp>
@@ -25414,7 +24292,7 @@
         <p:spPr>
           <a:xfrm>
             <a:off x="4434840" y="1508760"/>
-            <a:ext cx="3749039" cy="4133439"/>
+            <a:ext cx="3749039" cy="3687163"/>
           </a:xfrm>
           <a:prstGeom prst="rect">
             <a:avLst/>
@@ -25441,16 +24319,10 @@
               </a:defRPr>
             </a:pPr>
             <a:r>
-              <a:rPr sz="2400" dirty="0" smtClean="0">
+              <a:rPr sz="2400" dirty="0">
                 <a:latin typeface="Arial"/>
               </a:rPr>
-              <a:t>Project </a:t>
-            </a:r>
-            <a:r>
-              <a:rPr sz="2400" dirty="0">
-                <a:latin typeface="Arial"/>
-              </a:rPr>
-              <a:t>Scope</a:t>
+              <a:t>Work Breakdown Structure</a:t>
             </a:r>
           </a:p>
           <a:p>
@@ -25468,16 +24340,10 @@
               </a:defRPr>
             </a:pPr>
             <a:r>
-              <a:rPr sz="2400" dirty="0" smtClean="0">
+              <a:rPr sz="2400" dirty="0">
                 <a:latin typeface="Arial"/>
               </a:rPr>
-              <a:t>Work </a:t>
-            </a:r>
-            <a:r>
-              <a:rPr sz="2400" dirty="0">
-                <a:latin typeface="Arial"/>
-              </a:rPr>
-              <a:t>Breakdown Structure</a:t>
+              <a:t>Roles and Responsibilities</a:t>
             </a:r>
           </a:p>
           <a:p>
@@ -25495,16 +24361,10 @@
               </a:defRPr>
             </a:pPr>
             <a:r>
-              <a:rPr sz="2400" dirty="0" smtClean="0">
+              <a:rPr sz="2400" dirty="0">
                 <a:latin typeface="Arial"/>
               </a:rPr>
-              <a:t>Roles </a:t>
-            </a:r>
-            <a:r>
-              <a:rPr sz="2400" dirty="0">
-                <a:latin typeface="Arial"/>
-              </a:rPr>
-              <a:t>and Responsibilities</a:t>
+              <a:t>Constraints and Limitations</a:t>
             </a:r>
           </a:p>
           <a:p>
@@ -25522,16 +24382,10 @@
               </a:defRPr>
             </a:pPr>
             <a:r>
-              <a:rPr sz="2400" dirty="0" smtClean="0">
+              <a:rPr sz="2400" dirty="0">
                 <a:latin typeface="Arial"/>
               </a:rPr>
-              <a:t>Constraints </a:t>
-            </a:r>
-            <a:r>
-              <a:rPr sz="2400" dirty="0">
-                <a:latin typeface="Arial"/>
-              </a:rPr>
-              <a:t>and Limitations</a:t>
+              <a:t>Expected Benefits and Success Criteria</a:t>
             </a:r>
           </a:p>
           <a:p>
@@ -25549,43 +24403,10 @@
               </a:defRPr>
             </a:pPr>
             <a:r>
-              <a:rPr sz="2400" dirty="0" smtClean="0">
+              <a:rPr sz="2400" dirty="0">
                 <a:latin typeface="Arial"/>
               </a:rPr>
-              <a:t>Expected </a:t>
-            </a:r>
-            <a:r>
-              <a:rPr sz="2400" dirty="0">
-                <a:latin typeface="Arial"/>
-              </a:rPr>
-              <a:t>Benefits and Success Criteria</a:t>
-            </a:r>
-          </a:p>
-          <a:p>
-            <a:pPr marL="342900" indent="-342900">
-              <a:spcAft>
-                <a:spcPts val="600"/>
-              </a:spcAft>
-              <a:buFont typeface="Arial" panose="020B0604020202020204" pitchFamily="34" charset="0"/>
-              <a:buChar char="•"/>
-              <a:defRPr sz="1600">
-                <a:solidFill>
-                  <a:srgbClr val="141414"/>
-                </a:solidFill>
-                <a:latin typeface="Arial"/>
-              </a:defRPr>
-            </a:pPr>
-            <a:r>
-              <a:rPr sz="2400" dirty="0" smtClean="0">
-                <a:latin typeface="Arial"/>
-              </a:rPr>
-              <a:t>Conclusion </a:t>
-            </a:r>
-            <a:r>
-              <a:rPr sz="2400" dirty="0">
-                <a:latin typeface="Arial"/>
-              </a:rPr>
-              <a:t>and Q&amp;A</a:t>
+              <a:t>Conclusion and Q&amp;A</a:t>
             </a:r>
           </a:p>
         </p:txBody>
@@ -25607,13 +24428,6 @@
       </p:transition>
     </mc:Fallback>
   </mc:AlternateContent>
-  <p:timing>
-    <p:tnLst>
-      <p:par>
-        <p:cTn id="1" dur="indefinite" restart="never" nodeType="tmRoot"/>
-      </p:par>
-    </p:tnLst>
-  </p:timing>
 </p:sld>
 </file>
 
@@ -25692,13 +24506,6 @@
       </p:transition>
     </mc:Fallback>
   </mc:AlternateContent>
-  <p:timing>
-    <p:tnLst>
-      <p:par>
-        <p:cTn id="1" dur="indefinite" restart="never" nodeType="tmRoot"/>
-      </p:par>
-    </p:tnLst>
-  </p:timing>
 </p:sld>
 </file>
 
@@ -25915,19 +24722,10 @@
                 </a:solidFill>
                 <a:latin typeface="Arial"/>
               </a:rPr>
-              <a:t>An FIR formally opens the criminal justice process. It records the reported offence, identifies the </a:t>
+              <a:t>An FIR formally opens the criminal justice process. It records the reported offence, identifies the parties</a:t>
             </a:r>
             <a:r>
-              <a:rPr sz="1600" b="0" dirty="0" smtClean="0">
-                <a:solidFill>
-                  <a:srgbClr val="141414"/>
-                </a:solidFill>
-                <a:latin typeface="Arial"/>
-              </a:rPr>
-              <a:t>parties</a:t>
-            </a:r>
-            <a:r>
-              <a:rPr lang="en-US" sz="1600" b="0" dirty="0" smtClean="0">
+              <a:rPr lang="en-US" sz="1600" b="0" dirty="0">
                 <a:solidFill>
                   <a:srgbClr val="141414"/>
                 </a:solidFill>
@@ -25936,22 +24734,13 @@
               <a:t> and</a:t>
             </a:r>
             <a:r>
-              <a:rPr sz="1600" b="0" dirty="0" smtClean="0">
+              <a:rPr sz="1600" b="0" dirty="0">
                 <a:solidFill>
                   <a:srgbClr val="141414"/>
                 </a:solidFill>
                 <a:latin typeface="Arial"/>
               </a:rPr>
-              <a:t> </a:t>
-            </a:r>
-            <a:r>
-              <a:rPr sz="1600" b="0" dirty="0">
-                <a:solidFill>
-                  <a:srgbClr val="141414"/>
-                </a:solidFill>
-                <a:latin typeface="Arial"/>
-              </a:rPr>
-              <a:t>starts investigation.</a:t>
+              <a:t> starts investigation.</a:t>
             </a:r>
           </a:p>
         </p:txBody>
@@ -26111,19 +24900,10 @@
                 </a:solidFill>
                 <a:latin typeface="Arial"/>
               </a:rPr>
-              <a:t>Punjab, </a:t>
+              <a:t>Punjab, Sindh</a:t>
             </a:r>
             <a:r>
-              <a:rPr sz="1600" b="0" dirty="0" smtClean="0">
-                <a:solidFill>
-                  <a:srgbClr val="141414"/>
-                </a:solidFill>
-                <a:latin typeface="Arial"/>
-              </a:rPr>
-              <a:t>Sindh</a:t>
-            </a:r>
-            <a:r>
-              <a:rPr lang="en-US" sz="1600" b="0" dirty="0" smtClean="0">
+              <a:rPr lang="en-US" sz="1600" b="0" dirty="0">
                 <a:solidFill>
                   <a:srgbClr val="141414"/>
                 </a:solidFill>
@@ -26132,22 +24912,13 @@
               <a:t> and</a:t>
             </a:r>
             <a:r>
-              <a:rPr sz="1600" b="0" dirty="0" smtClean="0">
+              <a:rPr sz="1600" b="0" dirty="0">
                 <a:solidFill>
                   <a:srgbClr val="141414"/>
                 </a:solidFill>
                 <a:latin typeface="Arial"/>
               </a:rPr>
-              <a:t> </a:t>
-            </a:r>
-            <a:r>
-              <a:rPr sz="1600" b="0" dirty="0">
-                <a:solidFill>
-                  <a:srgbClr val="141414"/>
-                </a:solidFill>
-                <a:latin typeface="Arial"/>
-              </a:rPr>
-              <a:t>KP already use digital complaint and record systems. The project does not aim to replace these systems.</a:t>
+              <a:t> KP already use digital complaint and record systems. The project does not aim to replace these systems.</a:t>
             </a:r>
           </a:p>
         </p:txBody>
@@ -26325,19 +25096,10 @@
                 </a:solidFill>
                 <a:latin typeface="Arial"/>
               </a:rPr>
-              <a:t> Fabric layer for integrity, </a:t>
+              <a:t> Fabric layer for integrity, traceability</a:t>
             </a:r>
             <a:r>
-              <a:rPr sz="1600" b="0" dirty="0" smtClean="0">
-                <a:solidFill>
-                  <a:srgbClr val="141414"/>
-                </a:solidFill>
-                <a:latin typeface="Arial"/>
-              </a:rPr>
-              <a:t>traceability</a:t>
-            </a:r>
-            <a:r>
-              <a:rPr lang="en-US" sz="1600" b="0" dirty="0" smtClean="0">
+              <a:rPr lang="en-US" sz="1600" b="0" dirty="0">
                 <a:solidFill>
                   <a:srgbClr val="141414"/>
                 </a:solidFill>
@@ -26346,22 +25108,13 @@
               <a:t> and</a:t>
             </a:r>
             <a:r>
-              <a:rPr sz="1600" b="0" dirty="0" smtClean="0">
+              <a:rPr sz="1600" b="0" dirty="0">
                 <a:solidFill>
                   <a:srgbClr val="141414"/>
                 </a:solidFill>
                 <a:latin typeface="Arial"/>
               </a:rPr>
-              <a:t> </a:t>
-            </a:r>
-            <a:r>
-              <a:rPr sz="1600" b="0" dirty="0">
-                <a:solidFill>
-                  <a:srgbClr val="141414"/>
-                </a:solidFill>
-                <a:latin typeface="Arial"/>
-              </a:rPr>
-              <a:t>tamper evident auditing, while sensitive FIR data stays off chain.</a:t>
+              <a:t> tamper evident auditing, while sensitive FIR data stays off chain.</a:t>
             </a:r>
           </a:p>
         </p:txBody>
@@ -26374,13 +25127,6 @@
   <p:transition spd="med">
     <p:pull/>
   </p:transition>
-  <p:timing>
-    <p:tnLst>
-      <p:par>
-        <p:cTn id="1" dur="indefinite" restart="never" nodeType="tmRoot"/>
-      </p:par>
-    </p:tnLst>
-  </p:timing>
 </p:sld>
 </file>
 
@@ -26455,13 +25201,6 @@
   <p:transition spd="slow">
     <p:wipe/>
   </p:transition>
-  <p:timing>
-    <p:tnLst>
-      <p:par>
-        <p:cTn id="1" dur="indefinite" restart="never" nodeType="tmRoot"/>
-      </p:par>
-    </p:tnLst>
-  </p:timing>
 </p:sld>
 </file>
 
@@ -26548,11 +25287,41 @@
                 <a:tableStyleId>{5C22544A-7EE6-4342-B048-85BDC9FD1C3A}</a:tableStyleId>
               </a:tblPr>
               <a:tblGrid>
-                <a:gridCol w="2286000"/>
-                <a:gridCol w="1143000"/>
-                <a:gridCol w="1143000"/>
-                <a:gridCol w="1143000"/>
-                <a:gridCol w="2606040"/>
+                <a:gridCol w="2286000">
+                  <a:extLst>
+                    <a:ext uri="{9D8B030D-6E8A-4147-A177-3AD203B41FA5}">
+                      <a16:colId xmlns:a16="http://schemas.microsoft.com/office/drawing/2014/main" val="20000"/>
+                    </a:ext>
+                  </a:extLst>
+                </a:gridCol>
+                <a:gridCol w="1143000">
+                  <a:extLst>
+                    <a:ext uri="{9D8B030D-6E8A-4147-A177-3AD203B41FA5}">
+                      <a16:colId xmlns:a16="http://schemas.microsoft.com/office/drawing/2014/main" val="20001"/>
+                    </a:ext>
+                  </a:extLst>
+                </a:gridCol>
+                <a:gridCol w="1143000">
+                  <a:extLst>
+                    <a:ext uri="{9D8B030D-6E8A-4147-A177-3AD203B41FA5}">
+                      <a16:colId xmlns:a16="http://schemas.microsoft.com/office/drawing/2014/main" val="20002"/>
+                    </a:ext>
+                  </a:extLst>
+                </a:gridCol>
+                <a:gridCol w="1143000">
+                  <a:extLst>
+                    <a:ext uri="{9D8B030D-6E8A-4147-A177-3AD203B41FA5}">
+                      <a16:colId xmlns:a16="http://schemas.microsoft.com/office/drawing/2014/main" val="20003"/>
+                    </a:ext>
+                  </a:extLst>
+                </a:gridCol>
+                <a:gridCol w="2606040">
+                  <a:extLst>
+                    <a:ext uri="{9D8B030D-6E8A-4147-A177-3AD203B41FA5}">
+                      <a16:colId xmlns:a16="http://schemas.microsoft.com/office/drawing/2014/main" val="20004"/>
+                    </a:ext>
+                  </a:extLst>
+                </a:gridCol>
               </a:tblGrid>
               <a:tr h="560070">
                 <a:tc>
@@ -26670,6 +25439,11 @@
                     </a:solidFill>
                   </a:tcPr>
                 </a:tc>
+                <a:extLst>
+                  <a:ext uri="{0D108BD9-81ED-4DB2-BD59-A6C34878D82A}">
+                    <a16:rowId xmlns:a16="http://schemas.microsoft.com/office/drawing/2014/main" val="10000"/>
+                  </a:ext>
+                </a:extLst>
               </a:tr>
               <a:tr h="560070">
                 <a:tc>
@@ -26787,6 +25561,11 @@
                     </a:solidFill>
                   </a:tcPr>
                 </a:tc>
+                <a:extLst>
+                  <a:ext uri="{0D108BD9-81ED-4DB2-BD59-A6C34878D82A}">
+                    <a16:rowId xmlns:a16="http://schemas.microsoft.com/office/drawing/2014/main" val="10001"/>
+                  </a:ext>
+                </a:extLst>
               </a:tr>
               <a:tr h="560070">
                 <a:tc>
@@ -26904,6 +25683,11 @@
                     </a:solidFill>
                   </a:tcPr>
                 </a:tc>
+                <a:extLst>
+                  <a:ext uri="{0D108BD9-81ED-4DB2-BD59-A6C34878D82A}">
+                    <a16:rowId xmlns:a16="http://schemas.microsoft.com/office/drawing/2014/main" val="10002"/>
+                  </a:ext>
+                </a:extLst>
               </a:tr>
               <a:tr h="560070">
                 <a:tc>
@@ -27021,6 +25805,11 @@
                     </a:solidFill>
                   </a:tcPr>
                 </a:tc>
+                <a:extLst>
+                  <a:ext uri="{0D108BD9-81ED-4DB2-BD59-A6C34878D82A}">
+                    <a16:rowId xmlns:a16="http://schemas.microsoft.com/office/drawing/2014/main" val="10003"/>
+                  </a:ext>
+                </a:extLst>
               </a:tr>
               <a:tr h="560070">
                 <a:tc>
@@ -27138,6 +25927,11 @@
                     </a:solidFill>
                   </a:tcPr>
                 </a:tc>
+                <a:extLst>
+                  <a:ext uri="{0D108BD9-81ED-4DB2-BD59-A6C34878D82A}">
+                    <a16:rowId xmlns:a16="http://schemas.microsoft.com/office/drawing/2014/main" val="10004"/>
+                  </a:ext>
+                </a:extLst>
               </a:tr>
               <a:tr h="560070">
                 <a:tc>
@@ -27255,6 +26049,11 @@
                     </a:solidFill>
                   </a:tcPr>
                 </a:tc>
+                <a:extLst>
+                  <a:ext uri="{0D108BD9-81ED-4DB2-BD59-A6C34878D82A}">
+                    <a16:rowId xmlns:a16="http://schemas.microsoft.com/office/drawing/2014/main" val="10005"/>
+                  </a:ext>
+                </a:extLst>
               </a:tr>
               <a:tr h="560070">
                 <a:tc>
@@ -27372,6 +26171,11 @@
                     </a:solidFill>
                   </a:tcPr>
                 </a:tc>
+                <a:extLst>
+                  <a:ext uri="{0D108BD9-81ED-4DB2-BD59-A6C34878D82A}">
+                    <a16:rowId xmlns:a16="http://schemas.microsoft.com/office/drawing/2014/main" val="10006"/>
+                  </a:ext>
+                </a:extLst>
               </a:tr>
               <a:tr h="560070">
                 <a:tc>
@@ -27489,6 +26293,11 @@
                     </a:solidFill>
                   </a:tcPr>
                 </a:tc>
+                <a:extLst>
+                  <a:ext uri="{0D108BD9-81ED-4DB2-BD59-A6C34878D82A}">
+                    <a16:rowId xmlns:a16="http://schemas.microsoft.com/office/drawing/2014/main" val="10007"/>
+                  </a:ext>
+                </a:extLst>
               </a:tr>
             </a:tbl>
           </a:graphicData>
@@ -27502,13 +26311,6 @@
   <p:transition spd="slow">
     <p:push dir="u"/>
   </p:transition>
-  <p:timing>
-    <p:tnLst>
-      <p:par>
-        <p:cTn id="1" dur="indefinite" restart="never" nodeType="tmRoot"/>
-      </p:par>
-    </p:tnLst>
-  </p:timing>
 </p:sld>
 </file>
 
@@ -27569,23 +26371,7 @@
             </a:pPr>
             <a:r>
               <a:rPr lang="en-US" sz="1600" dirty="0"/>
-              <a:t>Digital police systems are already being used in Punjab, </a:t>
-            </a:r>
-            <a:r>
-              <a:rPr lang="en-US" sz="1600" dirty="0" smtClean="0"/>
-              <a:t>Sindh and </a:t>
-            </a:r>
-            <a:r>
-              <a:rPr lang="en-US" sz="1600" dirty="0"/>
-              <a:t>Khyber Pakhtunkhwa for complaints, FIR records, case </a:t>
-            </a:r>
-            <a:r>
-              <a:rPr lang="en-US" sz="1600" dirty="0" smtClean="0"/>
-              <a:t>tracking </a:t>
-            </a:r>
-            <a:r>
-              <a:rPr lang="en-US" sz="1600" dirty="0"/>
-              <a:t>and officer management.</a:t>
+              <a:t>Digital police systems are already being used in Punjab, Sindh and Khyber Pakhtunkhwa for complaints, FIR records, case tracking and officer management.</a:t>
             </a:r>
           </a:p>
           <a:p>
@@ -27607,15 +26393,7 @@
             </a:pPr>
             <a:r>
               <a:rPr lang="en-US" sz="1600" dirty="0"/>
-              <a:t>These systems have improved the way police records are created, </a:t>
-            </a:r>
-            <a:r>
-              <a:rPr lang="en-US" sz="1600" dirty="0" smtClean="0"/>
-              <a:t>stored and </a:t>
-            </a:r>
-            <a:r>
-              <a:rPr lang="en-US" sz="1600" dirty="0"/>
-              <a:t>accessed.</a:t>
+              <a:t>These systems have improved the way police records are created, stored and accessed.</a:t>
             </a:r>
           </a:p>
           <a:p>
@@ -27725,15 +26503,7 @@
             </a:pPr>
             <a:r>
               <a:rPr lang="en-US" sz="1600" dirty="0"/>
-              <a:t>Based on the reviewed systems, there is an opportunity to combine digital FIR management, blockchain, hashing, </a:t>
-            </a:r>
-            <a:r>
-              <a:rPr lang="en-US" sz="1600" dirty="0" smtClean="0"/>
-              <a:t>RBAC and </a:t>
-            </a:r>
-            <a:r>
-              <a:rPr lang="en-US" sz="1600" dirty="0"/>
-              <a:t>audit tracking in one system.</a:t>
+              <a:t>Based on the reviewed systems, there is an opportunity to combine digital FIR management, blockchain, hashing, RBAC and audit tracking in one system.</a:t>
             </a:r>
             <a:endParaRPr sz="1600" dirty="0"/>
           </a:p>
@@ -27761,13 +26531,6 @@
       </p:transition>
     </mc:Fallback>
   </mc:AlternateContent>
-  <p:timing>
-    <p:tnLst>
-      <p:par>
-        <p:cTn id="1" dur="indefinite" restart="never" nodeType="tmRoot"/>
-      </p:par>
-    </p:tnLst>
-  </p:timing>
 </p:sld>
 </file>
 
@@ -27846,13 +26609,6 @@
       </p:transition>
     </mc:Fallback>
   </mc:AlternateContent>
-  <p:timing>
-    <p:tnLst>
-      <p:par>
-        <p:cTn id="1" dur="indefinite" restart="never" nodeType="tmRoot"/>
-      </p:par>
-    </p:tnLst>
-  </p:timing>
 </p:sld>
 </file>
 

</xml_diff>